<commit_message>
feat: SQLite→PostgreSQL migration + 天翼云ECS prod deploy
- Add db.py: unified DB connection (PG primary + SQLite fallback)
- Add migrate_sqlite_to_pg.py: data migration script with --dry-run
- Update 6 Python files: 26 sqlite3.connect calls migrated to db.py
- Update deploy_to_ctyun.sh: PG install + init + pg_hba.conf + systemd DATABASE_URL
- Update DEPLOY天翼云.md: v1.2→v1.3 with PG migration section
- Update config.yaml.example: add database config section
- Update requirements.txt: add psycopg2-binary>=2.9
- Update PPT: upgraded contest deck with PG/deploy updates
- Update delivery-notes.md: record migration deliverables
</commit_message>
<xml_diff>
--- a/docs/成军台_息壤杯预赛答辩.pptx
+++ b/docs/成军台_息壤杯预赛答辩.pptx
@@ -1,25 +1,28 @@
 
 <file path=ppt/presentation.xml><?xml version="1.0" encoding="utf-8"?>
-<p:presentation xmlns:a="http://schemas.openxmlformats.org/drawingml/2006/main" xmlns:r="http://schemas.openxmlformats.org/officeDocument/2006/relationships" xmlns:p="http://schemas.openxmlformats.org/presentationml/2006/main" saveSubsetFonts="1" autoCompressPictures="0">
+<p:presentation xmlns:a="http://schemas.openxmlformats.org/drawingml/2006/main" xmlns:r="http://schemas.openxmlformats.org/officeDocument/2006/relationships" xmlns:p="http://schemas.openxmlformats.org/presentationml/2006/main" autoCompressPictures="0">
   <p:sldMasterIdLst>
     <p:sldMasterId id="2147483648" r:id="rId1"/>
   </p:sldMasterIdLst>
+  <p:notesMasterIdLst>
+    <p:notesMasterId r:id="rId4"/>
+  </p:notesMasterIdLst>
   <p:sldIdLst>
-    <p:sldId id="256" r:id="rId7"/>
-    <p:sldId id="257" r:id="rId9"/>
-    <p:sldId id="258" r:id="rId10"/>
-    <p:sldId id="259" r:id="rId11"/>
-    <p:sldId id="260" r:id="rId12"/>
-    <p:sldId id="261" r:id="rId13"/>
-    <p:sldId id="262" r:id="rId14"/>
-    <p:sldId id="263" r:id="rId15"/>
-    <p:sldId id="264" r:id="rId16"/>
-    <p:sldId id="265" r:id="rId17"/>
-    <p:sldId id="266" r:id="rId18"/>
-    <p:sldId id="267" r:id="rId19"/>
-    <p:sldId id="268" r:id="rId20"/>
+    <p:sldId id="256" r:id="rId3"/>
+    <p:sldId id="257" r:id="rId5"/>
+    <p:sldId id="258" r:id="rId6"/>
+    <p:sldId id="259" r:id="rId7"/>
+    <p:sldId id="260" r:id="rId8"/>
+    <p:sldId id="261" r:id="rId9"/>
+    <p:sldId id="262" r:id="rId10"/>
+    <p:sldId id="263" r:id="rId11"/>
+    <p:sldId id="264" r:id="rId12"/>
+    <p:sldId id="265" r:id="rId13"/>
+    <p:sldId id="266" r:id="rId14"/>
+    <p:sldId id="267" r:id="rId15"/>
+    <p:sldId id="268" r:id="rId16"/>
   </p:sldIdLst>
-  <p:sldSz cx="12191695" cy="6858000" type="screen4x3"/>
+  <p:sldSz cx="12191365" cy="6858000" type="screen4x3"/>
   <p:notesSz cx="6858000" cy="9144000"/>
   <p:defaultTextStyle>
     <a:defPPr>
@@ -116,11 +119,27 @@
       </a:defRPr>
     </a:lvl9pPr>
   </p:defaultTextStyle>
+  <p:extLst>
+    <p:ext uri="{EFAFB233-063F-42B5-8137-9DF3F51BA10A}">
+      <p15:sldGuideLst xmlns:p15="http://schemas.microsoft.com/office/powerpoint/2012/main">
+        <p15:guide id="1" orient="horz" pos="2160" userDrawn="1">
+          <p15:clr>
+            <a:srgbClr val="A4A3A4"/>
+          </p15:clr>
+        </p15:guide>
+        <p15:guide id="2" pos="2880" userDrawn="1">
+          <p15:clr>
+            <a:srgbClr val="A4A3A4"/>
+          </p15:clr>
+        </p15:guide>
+      </p15:sldGuideLst>
+    </p:ext>
+  </p:extLst>
 </p:presentation>
 </file>
 
 <file path=ppt/notesMasters/notesMaster1.xml><?xml version="1.0" encoding="utf-8"?>
-<p:notesMaster xmlns:a="http://schemas.openxmlformats.org/drawingml/2006/main" xmlns:p="http://schemas.openxmlformats.org/presentationml/2006/main" xmlns:r="http://schemas.openxmlformats.org/officeDocument/2006/relationships">
+<p:notesMaster xmlns:a="http://schemas.openxmlformats.org/drawingml/2006/main" xmlns:r="http://schemas.openxmlformats.org/officeDocument/2006/relationships" xmlns:p="http://schemas.openxmlformats.org/presentationml/2006/main">
   <p:cSld>
     <p:bg>
       <p:bgRef idx="1001">
@@ -201,7 +220,6 @@
           <a:p>
             <a:fld id="{0F89C1C7-3DCD-1040-A9CF-14679D8B5DDD}" type="datetimeFigureOut">
               <a:rPr lang="en-US" smtClean="0"/>
-              <a:t>10/17/16</a:t>
             </a:fld>
             <a:endParaRPr lang="en-US"/>
           </a:p>
@@ -268,6 +286,7 @@
               <a:rPr lang="en-US" smtClean="0"/>
               <a:t>Click to edit Master text styles</a:t>
             </a:r>
+            <a:endParaRPr lang="en-US" smtClean="0"/>
           </a:p>
           <a:p>
             <a:pPr lvl="1"/>
@@ -275,6 +294,7 @@
               <a:rPr lang="en-US" smtClean="0"/>
               <a:t>Second level</a:t>
             </a:r>
+            <a:endParaRPr lang="en-US" smtClean="0"/>
           </a:p>
           <a:p>
             <a:pPr lvl="2"/>
@@ -282,6 +302,7 @@
               <a:rPr lang="en-US" smtClean="0"/>
               <a:t>Third level</a:t>
             </a:r>
+            <a:endParaRPr lang="en-US" smtClean="0"/>
           </a:p>
           <a:p>
             <a:pPr lvl="3"/>
@@ -289,6 +310,7 @@
               <a:rPr lang="en-US" smtClean="0"/>
               <a:t>Fourth level</a:t>
             </a:r>
+            <a:endParaRPr lang="en-US" smtClean="0"/>
           </a:p>
           <a:p>
             <a:pPr lvl="4"/>
@@ -360,18 +382,12 @@
           <a:p>
             <a:fld id="{BB5E49A5-4136-284D-997B-48E1D791AD67}" type="slidenum">
               <a:rPr lang="en-US" smtClean="0"/>
-              <a:t>‹#›</a:t>
             </a:fld>
             <a:endParaRPr lang="en-US"/>
           </a:p>
         </p:txBody>
       </p:sp>
     </p:spTree>
-    <p:extLst>
-      <p:ext uri="{BB962C8B-B14F-4D97-AF65-F5344CB8AC3E}">
-        <p14:creationId xmlns:p14="http://schemas.microsoft.com/office/powerpoint/2010/main" val="2623252185"/>
-      </p:ext>
-    </p:extLst>
   </p:cSld>
   <p:clrMap bg1="lt1" tx1="dk1" bg2="lt2" tx2="dk2" accent1="accent1" accent2="accent2" accent3="accent3" accent4="accent4" accent5="accent5" accent6="accent6" hlink="hlink" folHlink="folHlink"/>
   <p:notesStyle>
@@ -470,7 +486,7 @@
 </file>
 
 <file path=ppt/notesSlides/notesSlide1.xml><?xml version="1.0" encoding="utf-8"?>
-<p:notes xmlns:a="http://schemas.openxmlformats.org/drawingml/2006/main" xmlns:p="http://schemas.openxmlformats.org/presentationml/2006/main" xmlns:r="http://schemas.openxmlformats.org/officeDocument/2006/relationships">
+<p:notes xmlns:a="http://schemas.openxmlformats.org/drawingml/2006/main" xmlns:r="http://schemas.openxmlformats.org/officeDocument/2006/relationships" xmlns:p="http://schemas.openxmlformats.org/presentationml/2006/main">
   <p:cSld>
     <p:spTree>
       <p:nvGrpSpPr>
@@ -505,7 +521,7 @@
             <a:spLocks noGrp="1"/>
           </p:cNvSpPr>
           <p:nvPr>
-            <p:ph type="body" idx="3" sz="quarter"/>
+            <p:ph type="body" sz="quarter" idx="3"/>
           </p:nvPr>
         </p:nvSpPr>
         <p:spPr/>
@@ -526,7 +542,7 @@
             <a:spLocks noGrp="1"/>
           </p:cNvSpPr>
           <p:nvPr>
-            <p:ph type="sldNum" idx="5" sz="quarter"/>
+            <p:ph type="sldNum" sz="quarter" idx="5"/>
           </p:nvPr>
         </p:nvSpPr>
         <p:spPr/>
@@ -540,7 +556,7 @@
 </file>
 
 <file path=ppt/notesSlides/notesSlide10.xml><?xml version="1.0" encoding="utf-8"?>
-<p:notes xmlns:a="http://schemas.openxmlformats.org/drawingml/2006/main" xmlns:p="http://schemas.openxmlformats.org/presentationml/2006/main" xmlns:r="http://schemas.openxmlformats.org/officeDocument/2006/relationships">
+<p:notes xmlns:a="http://schemas.openxmlformats.org/drawingml/2006/main" xmlns:r="http://schemas.openxmlformats.org/officeDocument/2006/relationships" xmlns:p="http://schemas.openxmlformats.org/presentationml/2006/main">
   <p:cSld>
     <p:spTree>
       <p:nvGrpSpPr>
@@ -575,7 +591,7 @@
             <a:spLocks noGrp="1"/>
           </p:cNvSpPr>
           <p:nvPr>
-            <p:ph type="body" idx="3" sz="quarter"/>
+            <p:ph type="body" sz="quarter" idx="3"/>
           </p:nvPr>
         </p:nvSpPr>
         <p:spPr/>
@@ -596,7 +612,7 @@
             <a:spLocks noGrp="1"/>
           </p:cNvSpPr>
           <p:nvPr>
-            <p:ph type="sldNum" idx="5" sz="quarter"/>
+            <p:ph type="sldNum" sz="quarter" idx="5"/>
           </p:nvPr>
         </p:nvSpPr>
         <p:spPr/>
@@ -610,7 +626,7 @@
 </file>
 
 <file path=ppt/notesSlides/notesSlide11.xml><?xml version="1.0" encoding="utf-8"?>
-<p:notes xmlns:a="http://schemas.openxmlformats.org/drawingml/2006/main" xmlns:p="http://schemas.openxmlformats.org/presentationml/2006/main" xmlns:r="http://schemas.openxmlformats.org/officeDocument/2006/relationships">
+<p:notes xmlns:a="http://schemas.openxmlformats.org/drawingml/2006/main" xmlns:r="http://schemas.openxmlformats.org/officeDocument/2006/relationships" xmlns:p="http://schemas.openxmlformats.org/presentationml/2006/main">
   <p:cSld>
     <p:spTree>
       <p:nvGrpSpPr>
@@ -645,7 +661,7 @@
             <a:spLocks noGrp="1"/>
           </p:cNvSpPr>
           <p:nvPr>
-            <p:ph type="body" idx="3" sz="quarter"/>
+            <p:ph type="body" sz="quarter" idx="3"/>
           </p:nvPr>
         </p:nvSpPr>
         <p:spPr/>
@@ -666,7 +682,7 @@
             <a:spLocks noGrp="1"/>
           </p:cNvSpPr>
           <p:nvPr>
-            <p:ph type="sldNum" idx="5" sz="quarter"/>
+            <p:ph type="sldNum" sz="quarter" idx="5"/>
           </p:nvPr>
         </p:nvSpPr>
         <p:spPr/>
@@ -680,7 +696,7 @@
 </file>
 
 <file path=ppt/notesSlides/notesSlide12.xml><?xml version="1.0" encoding="utf-8"?>
-<p:notes xmlns:a="http://schemas.openxmlformats.org/drawingml/2006/main" xmlns:p="http://schemas.openxmlformats.org/presentationml/2006/main" xmlns:r="http://schemas.openxmlformats.org/officeDocument/2006/relationships">
+<p:notes xmlns:a="http://schemas.openxmlformats.org/drawingml/2006/main" xmlns:r="http://schemas.openxmlformats.org/officeDocument/2006/relationships" xmlns:p="http://schemas.openxmlformats.org/presentationml/2006/main">
   <p:cSld>
     <p:spTree>
       <p:nvGrpSpPr>
@@ -715,7 +731,7 @@
             <a:spLocks noGrp="1"/>
           </p:cNvSpPr>
           <p:nvPr>
-            <p:ph type="body" idx="3" sz="quarter"/>
+            <p:ph type="body" sz="quarter" idx="3"/>
           </p:nvPr>
         </p:nvSpPr>
         <p:spPr/>
@@ -736,7 +752,7 @@
             <a:spLocks noGrp="1"/>
           </p:cNvSpPr>
           <p:nvPr>
-            <p:ph type="sldNum" idx="5" sz="quarter"/>
+            <p:ph type="sldNum" sz="quarter" idx="5"/>
           </p:nvPr>
         </p:nvSpPr>
         <p:spPr/>
@@ -750,7 +766,7 @@
 </file>
 
 <file path=ppt/notesSlides/notesSlide13.xml><?xml version="1.0" encoding="utf-8"?>
-<p:notes xmlns:a="http://schemas.openxmlformats.org/drawingml/2006/main" xmlns:p="http://schemas.openxmlformats.org/presentationml/2006/main" xmlns:r="http://schemas.openxmlformats.org/officeDocument/2006/relationships">
+<p:notes xmlns:a="http://schemas.openxmlformats.org/drawingml/2006/main" xmlns:r="http://schemas.openxmlformats.org/officeDocument/2006/relationships" xmlns:p="http://schemas.openxmlformats.org/presentationml/2006/main">
   <p:cSld>
     <p:spTree>
       <p:nvGrpSpPr>
@@ -785,7 +801,7 @@
             <a:spLocks noGrp="1"/>
           </p:cNvSpPr>
           <p:nvPr>
-            <p:ph type="body" idx="3" sz="quarter"/>
+            <p:ph type="body" sz="quarter" idx="3"/>
           </p:nvPr>
         </p:nvSpPr>
         <p:spPr/>
@@ -806,7 +822,7 @@
             <a:spLocks noGrp="1"/>
           </p:cNvSpPr>
           <p:nvPr>
-            <p:ph type="sldNum" idx="5" sz="quarter"/>
+            <p:ph type="sldNum" sz="quarter" idx="5"/>
           </p:nvPr>
         </p:nvSpPr>
         <p:spPr/>
@@ -820,7 +836,7 @@
 </file>
 
 <file path=ppt/notesSlides/notesSlide2.xml><?xml version="1.0" encoding="utf-8"?>
-<p:notes xmlns:a="http://schemas.openxmlformats.org/drawingml/2006/main" xmlns:p="http://schemas.openxmlformats.org/presentationml/2006/main" xmlns:r="http://schemas.openxmlformats.org/officeDocument/2006/relationships">
+<p:notes xmlns:a="http://schemas.openxmlformats.org/drawingml/2006/main" xmlns:r="http://schemas.openxmlformats.org/officeDocument/2006/relationships" xmlns:p="http://schemas.openxmlformats.org/presentationml/2006/main">
   <p:cSld>
     <p:spTree>
       <p:nvGrpSpPr>
@@ -855,7 +871,7 @@
             <a:spLocks noGrp="1"/>
           </p:cNvSpPr>
           <p:nvPr>
-            <p:ph type="body" idx="3" sz="quarter"/>
+            <p:ph type="body" sz="quarter" idx="3"/>
           </p:nvPr>
         </p:nvSpPr>
         <p:spPr/>
@@ -876,7 +892,7 @@
             <a:spLocks noGrp="1"/>
           </p:cNvSpPr>
           <p:nvPr>
-            <p:ph type="sldNum" idx="5" sz="quarter"/>
+            <p:ph type="sldNum" sz="quarter" idx="5"/>
           </p:nvPr>
         </p:nvSpPr>
         <p:spPr/>
@@ -890,7 +906,7 @@
 </file>
 
 <file path=ppt/notesSlides/notesSlide3.xml><?xml version="1.0" encoding="utf-8"?>
-<p:notes xmlns:a="http://schemas.openxmlformats.org/drawingml/2006/main" xmlns:p="http://schemas.openxmlformats.org/presentationml/2006/main" xmlns:r="http://schemas.openxmlformats.org/officeDocument/2006/relationships">
+<p:notes xmlns:a="http://schemas.openxmlformats.org/drawingml/2006/main" xmlns:r="http://schemas.openxmlformats.org/officeDocument/2006/relationships" xmlns:p="http://schemas.openxmlformats.org/presentationml/2006/main">
   <p:cSld>
     <p:spTree>
       <p:nvGrpSpPr>
@@ -925,7 +941,7 @@
             <a:spLocks noGrp="1"/>
           </p:cNvSpPr>
           <p:nvPr>
-            <p:ph type="body" idx="3" sz="quarter"/>
+            <p:ph type="body" sz="quarter" idx="3"/>
           </p:nvPr>
         </p:nvSpPr>
         <p:spPr/>
@@ -946,7 +962,7 @@
             <a:spLocks noGrp="1"/>
           </p:cNvSpPr>
           <p:nvPr>
-            <p:ph type="sldNum" idx="5" sz="quarter"/>
+            <p:ph type="sldNum" sz="quarter" idx="5"/>
           </p:nvPr>
         </p:nvSpPr>
         <p:spPr/>
@@ -960,7 +976,7 @@
 </file>
 
 <file path=ppt/notesSlides/notesSlide4.xml><?xml version="1.0" encoding="utf-8"?>
-<p:notes xmlns:a="http://schemas.openxmlformats.org/drawingml/2006/main" xmlns:p="http://schemas.openxmlformats.org/presentationml/2006/main" xmlns:r="http://schemas.openxmlformats.org/officeDocument/2006/relationships">
+<p:notes xmlns:a="http://schemas.openxmlformats.org/drawingml/2006/main" xmlns:r="http://schemas.openxmlformats.org/officeDocument/2006/relationships" xmlns:p="http://schemas.openxmlformats.org/presentationml/2006/main">
   <p:cSld>
     <p:spTree>
       <p:nvGrpSpPr>
@@ -995,7 +1011,7 @@
             <a:spLocks noGrp="1"/>
           </p:cNvSpPr>
           <p:nvPr>
-            <p:ph type="body" idx="3" sz="quarter"/>
+            <p:ph type="body" sz="quarter" idx="3"/>
           </p:nvPr>
         </p:nvSpPr>
         <p:spPr/>
@@ -1016,7 +1032,7 @@
             <a:spLocks noGrp="1"/>
           </p:cNvSpPr>
           <p:nvPr>
-            <p:ph type="sldNum" idx="5" sz="quarter"/>
+            <p:ph type="sldNum" sz="quarter" idx="5"/>
           </p:nvPr>
         </p:nvSpPr>
         <p:spPr/>
@@ -1030,7 +1046,7 @@
 </file>
 
 <file path=ppt/notesSlides/notesSlide5.xml><?xml version="1.0" encoding="utf-8"?>
-<p:notes xmlns:a="http://schemas.openxmlformats.org/drawingml/2006/main" xmlns:p="http://schemas.openxmlformats.org/presentationml/2006/main" xmlns:r="http://schemas.openxmlformats.org/officeDocument/2006/relationships">
+<p:notes xmlns:a="http://schemas.openxmlformats.org/drawingml/2006/main" xmlns:r="http://schemas.openxmlformats.org/officeDocument/2006/relationships" xmlns:p="http://schemas.openxmlformats.org/presentationml/2006/main">
   <p:cSld>
     <p:spTree>
       <p:nvGrpSpPr>
@@ -1065,7 +1081,7 @@
             <a:spLocks noGrp="1"/>
           </p:cNvSpPr>
           <p:nvPr>
-            <p:ph type="body" idx="3" sz="quarter"/>
+            <p:ph type="body" sz="quarter" idx="3"/>
           </p:nvPr>
         </p:nvSpPr>
         <p:spPr/>
@@ -1086,7 +1102,7 @@
             <a:spLocks noGrp="1"/>
           </p:cNvSpPr>
           <p:nvPr>
-            <p:ph type="sldNum" idx="5" sz="quarter"/>
+            <p:ph type="sldNum" sz="quarter" idx="5"/>
           </p:nvPr>
         </p:nvSpPr>
         <p:spPr/>
@@ -1100,7 +1116,7 @@
 </file>
 
 <file path=ppt/notesSlides/notesSlide6.xml><?xml version="1.0" encoding="utf-8"?>
-<p:notes xmlns:a="http://schemas.openxmlformats.org/drawingml/2006/main" xmlns:p="http://schemas.openxmlformats.org/presentationml/2006/main" xmlns:r="http://schemas.openxmlformats.org/officeDocument/2006/relationships">
+<p:notes xmlns:a="http://schemas.openxmlformats.org/drawingml/2006/main" xmlns:r="http://schemas.openxmlformats.org/officeDocument/2006/relationships" xmlns:p="http://schemas.openxmlformats.org/presentationml/2006/main">
   <p:cSld>
     <p:spTree>
       <p:nvGrpSpPr>
@@ -1135,7 +1151,7 @@
             <a:spLocks noGrp="1"/>
           </p:cNvSpPr>
           <p:nvPr>
-            <p:ph type="body" idx="3" sz="quarter"/>
+            <p:ph type="body" sz="quarter" idx="3"/>
           </p:nvPr>
         </p:nvSpPr>
         <p:spPr/>
@@ -1156,7 +1172,7 @@
             <a:spLocks noGrp="1"/>
           </p:cNvSpPr>
           <p:nvPr>
-            <p:ph type="sldNum" idx="5" sz="quarter"/>
+            <p:ph type="sldNum" sz="quarter" idx="5"/>
           </p:nvPr>
         </p:nvSpPr>
         <p:spPr/>
@@ -1170,7 +1186,7 @@
 </file>
 
 <file path=ppt/notesSlides/notesSlide7.xml><?xml version="1.0" encoding="utf-8"?>
-<p:notes xmlns:a="http://schemas.openxmlformats.org/drawingml/2006/main" xmlns:p="http://schemas.openxmlformats.org/presentationml/2006/main" xmlns:r="http://schemas.openxmlformats.org/officeDocument/2006/relationships">
+<p:notes xmlns:a="http://schemas.openxmlformats.org/drawingml/2006/main" xmlns:r="http://schemas.openxmlformats.org/officeDocument/2006/relationships" xmlns:p="http://schemas.openxmlformats.org/presentationml/2006/main">
   <p:cSld>
     <p:spTree>
       <p:nvGrpSpPr>
@@ -1205,7 +1221,7 @@
             <a:spLocks noGrp="1"/>
           </p:cNvSpPr>
           <p:nvPr>
-            <p:ph type="body" idx="3" sz="quarter"/>
+            <p:ph type="body" sz="quarter" idx="3"/>
           </p:nvPr>
         </p:nvSpPr>
         <p:spPr/>
@@ -1226,7 +1242,7 @@
             <a:spLocks noGrp="1"/>
           </p:cNvSpPr>
           <p:nvPr>
-            <p:ph type="sldNum" idx="5" sz="quarter"/>
+            <p:ph type="sldNum" sz="quarter" idx="5"/>
           </p:nvPr>
         </p:nvSpPr>
         <p:spPr/>
@@ -1240,7 +1256,7 @@
 </file>
 
 <file path=ppt/notesSlides/notesSlide8.xml><?xml version="1.0" encoding="utf-8"?>
-<p:notes xmlns:a="http://schemas.openxmlformats.org/drawingml/2006/main" xmlns:p="http://schemas.openxmlformats.org/presentationml/2006/main" xmlns:r="http://schemas.openxmlformats.org/officeDocument/2006/relationships">
+<p:notes xmlns:a="http://schemas.openxmlformats.org/drawingml/2006/main" xmlns:r="http://schemas.openxmlformats.org/officeDocument/2006/relationships" xmlns:p="http://schemas.openxmlformats.org/presentationml/2006/main">
   <p:cSld>
     <p:spTree>
       <p:nvGrpSpPr>
@@ -1275,7 +1291,7 @@
             <a:spLocks noGrp="1"/>
           </p:cNvSpPr>
           <p:nvPr>
-            <p:ph type="body" idx="3" sz="quarter"/>
+            <p:ph type="body" sz="quarter" idx="3"/>
           </p:nvPr>
         </p:nvSpPr>
         <p:spPr/>
@@ -1296,7 +1312,7 @@
             <a:spLocks noGrp="1"/>
           </p:cNvSpPr>
           <p:nvPr>
-            <p:ph type="sldNum" idx="5" sz="quarter"/>
+            <p:ph type="sldNum" sz="quarter" idx="5"/>
           </p:nvPr>
         </p:nvSpPr>
         <p:spPr/>
@@ -1310,7 +1326,7 @@
 </file>
 
 <file path=ppt/notesSlides/notesSlide9.xml><?xml version="1.0" encoding="utf-8"?>
-<p:notes xmlns:a="http://schemas.openxmlformats.org/drawingml/2006/main" xmlns:p="http://schemas.openxmlformats.org/presentationml/2006/main" xmlns:r="http://schemas.openxmlformats.org/officeDocument/2006/relationships">
+<p:notes xmlns:a="http://schemas.openxmlformats.org/drawingml/2006/main" xmlns:r="http://schemas.openxmlformats.org/officeDocument/2006/relationships" xmlns:p="http://schemas.openxmlformats.org/presentationml/2006/main">
   <p:cSld>
     <p:spTree>
       <p:nvGrpSpPr>
@@ -1345,7 +1361,7 @@
             <a:spLocks noGrp="1"/>
           </p:cNvSpPr>
           <p:nvPr>
-            <p:ph type="body" idx="3" sz="quarter"/>
+            <p:ph type="body" sz="quarter" idx="3"/>
           </p:nvPr>
         </p:nvSpPr>
         <p:spPr/>
@@ -1366,7 +1382,7 @@
             <a:spLocks noGrp="1"/>
           </p:cNvSpPr>
           <p:nvPr>
-            <p:ph type="sldNum" idx="5" sz="quarter"/>
+            <p:ph type="sldNum" sz="quarter" idx="5"/>
           </p:nvPr>
         </p:nvSpPr>
         <p:spPr/>
@@ -1560,7 +1576,6 @@
           <a:p>
             <a:fld id="{5BCAD085-E8A6-8845-BD4E-CB4CCA059FC4}" type="datetimeFigureOut">
               <a:rPr lang="en-US" smtClean="0"/>
-              <a:t>1/27/13</a:t>
             </a:fld>
             <a:endParaRPr lang="en-US"/>
           </a:p>
@@ -1602,18 +1617,12 @@
           <a:p>
             <a:fld id="{C1FF6DA9-008F-8B48-92A6-B652298478BF}" type="slidenum">
               <a:rPr lang="en-US" smtClean="0"/>
-              <a:t>‹#›</a:t>
             </a:fld>
             <a:endParaRPr lang="en-US"/>
           </a:p>
         </p:txBody>
       </p:sp>
     </p:spTree>
-    <p:extLst>
-      <p:ext uri="{BB962C8B-B14F-4D97-AF65-F5344CB8AC3E}">
-        <p14:creationId xmlns:p14="http://schemas.microsoft.com/office/powerpoint/2010/main" val="3168075583"/>
-      </p:ext>
-    </p:extLst>
   </p:cSld>
   <p:clrMapOvr>
     <a:masterClrMapping/>
@@ -1681,6 +1690,7 @@
               <a:rPr lang="en-US" smtClean="0"/>
               <a:t>Click to edit Master text styles</a:t>
             </a:r>
+            <a:endParaRPr lang="en-US" smtClean="0"/>
           </a:p>
           <a:p>
             <a:pPr lvl="1"/>
@@ -1688,6 +1698,7 @@
               <a:rPr lang="en-US" smtClean="0"/>
               <a:t>Second level</a:t>
             </a:r>
+            <a:endParaRPr lang="en-US" smtClean="0"/>
           </a:p>
           <a:p>
             <a:pPr lvl="2"/>
@@ -1695,6 +1706,7 @@
               <a:rPr lang="en-US" smtClean="0"/>
               <a:t>Third level</a:t>
             </a:r>
+            <a:endParaRPr lang="en-US" smtClean="0"/>
           </a:p>
           <a:p>
             <a:pPr lvl="3"/>
@@ -1702,6 +1714,7 @@
               <a:rPr lang="en-US" smtClean="0"/>
               <a:t>Fourth level</a:t>
             </a:r>
+            <a:endParaRPr lang="en-US" smtClean="0"/>
           </a:p>
           <a:p>
             <a:pPr lvl="4"/>
@@ -1730,7 +1743,6 @@
           <a:p>
             <a:fld id="{5BCAD085-E8A6-8845-BD4E-CB4CCA059FC4}" type="datetimeFigureOut">
               <a:rPr lang="en-US" smtClean="0"/>
-              <a:t>1/27/13</a:t>
             </a:fld>
             <a:endParaRPr lang="en-US"/>
           </a:p>
@@ -1772,18 +1784,12 @@
           <a:p>
             <a:fld id="{C1FF6DA9-008F-8B48-92A6-B652298478BF}" type="slidenum">
               <a:rPr lang="en-US" smtClean="0"/>
-              <a:t>‹#›</a:t>
             </a:fld>
             <a:endParaRPr lang="en-US"/>
           </a:p>
         </p:txBody>
       </p:sp>
     </p:spTree>
-    <p:extLst>
-      <p:ext uri="{BB962C8B-B14F-4D97-AF65-F5344CB8AC3E}">
-        <p14:creationId xmlns:p14="http://schemas.microsoft.com/office/powerpoint/2010/main" val="2910927964"/>
-      </p:ext>
-    </p:extLst>
   </p:cSld>
   <p:clrMapOvr>
     <a:masterClrMapping/>
@@ -1861,6 +1867,7 @@
               <a:rPr lang="en-US" smtClean="0"/>
               <a:t>Click to edit Master text styles</a:t>
             </a:r>
+            <a:endParaRPr lang="en-US" smtClean="0"/>
           </a:p>
           <a:p>
             <a:pPr lvl="1"/>
@@ -1868,6 +1875,7 @@
               <a:rPr lang="en-US" smtClean="0"/>
               <a:t>Second level</a:t>
             </a:r>
+            <a:endParaRPr lang="en-US" smtClean="0"/>
           </a:p>
           <a:p>
             <a:pPr lvl="2"/>
@@ -1875,6 +1883,7 @@
               <a:rPr lang="en-US" smtClean="0"/>
               <a:t>Third level</a:t>
             </a:r>
+            <a:endParaRPr lang="en-US" smtClean="0"/>
           </a:p>
           <a:p>
             <a:pPr lvl="3"/>
@@ -1882,6 +1891,7 @@
               <a:rPr lang="en-US" smtClean="0"/>
               <a:t>Fourth level</a:t>
             </a:r>
+            <a:endParaRPr lang="en-US" smtClean="0"/>
           </a:p>
           <a:p>
             <a:pPr lvl="4"/>
@@ -1910,7 +1920,6 @@
           <a:p>
             <a:fld id="{5BCAD085-E8A6-8845-BD4E-CB4CCA059FC4}" type="datetimeFigureOut">
               <a:rPr lang="en-US" smtClean="0"/>
-              <a:t>1/27/13</a:t>
             </a:fld>
             <a:endParaRPr lang="en-US"/>
           </a:p>
@@ -1952,18 +1961,12 @@
           <a:p>
             <a:fld id="{C1FF6DA9-008F-8B48-92A6-B652298478BF}" type="slidenum">
               <a:rPr lang="en-US" smtClean="0"/>
-              <a:t>‹#›</a:t>
             </a:fld>
             <a:endParaRPr lang="en-US"/>
           </a:p>
         </p:txBody>
       </p:sp>
     </p:spTree>
-    <p:extLst>
-      <p:ext uri="{BB962C8B-B14F-4D97-AF65-F5344CB8AC3E}">
-        <p14:creationId xmlns:p14="http://schemas.microsoft.com/office/powerpoint/2010/main" val="3612223792"/>
-      </p:ext>
-    </p:extLst>
   </p:cSld>
   <p:clrMapOvr>
     <a:masterClrMapping/>
@@ -2031,6 +2034,7 @@
               <a:rPr lang="en-US" smtClean="0"/>
               <a:t>Click to edit Master text styles</a:t>
             </a:r>
+            <a:endParaRPr lang="en-US" smtClean="0"/>
           </a:p>
           <a:p>
             <a:pPr lvl="1"/>
@@ -2038,6 +2042,7 @@
               <a:rPr lang="en-US" smtClean="0"/>
               <a:t>Second level</a:t>
             </a:r>
+            <a:endParaRPr lang="en-US" smtClean="0"/>
           </a:p>
           <a:p>
             <a:pPr lvl="2"/>
@@ -2045,6 +2050,7 @@
               <a:rPr lang="en-US" smtClean="0"/>
               <a:t>Third level</a:t>
             </a:r>
+            <a:endParaRPr lang="en-US" smtClean="0"/>
           </a:p>
           <a:p>
             <a:pPr lvl="3"/>
@@ -2052,6 +2058,7 @@
               <a:rPr lang="en-US" smtClean="0"/>
               <a:t>Fourth level</a:t>
             </a:r>
+            <a:endParaRPr lang="en-US" smtClean="0"/>
           </a:p>
           <a:p>
             <a:pPr lvl="4"/>
@@ -2080,7 +2087,6 @@
           <a:p>
             <a:fld id="{5BCAD085-E8A6-8845-BD4E-CB4CCA059FC4}" type="datetimeFigureOut">
               <a:rPr lang="en-US" smtClean="0"/>
-              <a:t>1/27/13</a:t>
             </a:fld>
             <a:endParaRPr lang="en-US"/>
           </a:p>
@@ -2122,18 +2128,12 @@
           <a:p>
             <a:fld id="{C1FF6DA9-008F-8B48-92A6-B652298478BF}" type="slidenum">
               <a:rPr lang="en-US" smtClean="0"/>
-              <a:t>‹#›</a:t>
             </a:fld>
             <a:endParaRPr lang="en-US"/>
           </a:p>
         </p:txBody>
       </p:sp>
     </p:spTree>
-    <p:extLst>
-      <p:ext uri="{BB962C8B-B14F-4D97-AF65-F5344CB8AC3E}">
-        <p14:creationId xmlns:p14="http://schemas.microsoft.com/office/powerpoint/2010/main" val="2614314258"/>
-      </p:ext>
-    </p:extLst>
   </p:cSld>
   <p:clrMapOvr>
     <a:masterClrMapping/>
@@ -2306,6 +2306,7 @@
               <a:rPr lang="en-US" smtClean="0"/>
               <a:t>Click to edit Master text styles</a:t>
             </a:r>
+            <a:endParaRPr lang="en-US" smtClean="0"/>
           </a:p>
         </p:txBody>
       </p:sp>
@@ -2326,7 +2327,6 @@
           <a:p>
             <a:fld id="{5BCAD085-E8A6-8845-BD4E-CB4CCA059FC4}" type="datetimeFigureOut">
               <a:rPr lang="en-US" smtClean="0"/>
-              <a:t>1/27/13</a:t>
             </a:fld>
             <a:endParaRPr lang="en-US"/>
           </a:p>
@@ -2368,18 +2368,12 @@
           <a:p>
             <a:fld id="{C1FF6DA9-008F-8B48-92A6-B652298478BF}" type="slidenum">
               <a:rPr lang="en-US" smtClean="0"/>
-              <a:t>‹#›</a:t>
             </a:fld>
             <a:endParaRPr lang="en-US"/>
           </a:p>
         </p:txBody>
       </p:sp>
     </p:spTree>
-    <p:extLst>
-      <p:ext uri="{BB962C8B-B14F-4D97-AF65-F5344CB8AC3E}">
-        <p14:creationId xmlns:p14="http://schemas.microsoft.com/office/powerpoint/2010/main" val="960648375"/>
-      </p:ext>
-    </p:extLst>
   </p:cSld>
   <p:clrMapOvr>
     <a:masterClrMapping/>
@@ -2480,6 +2474,7 @@
               <a:rPr lang="en-US" smtClean="0"/>
               <a:t>Click to edit Master text styles</a:t>
             </a:r>
+            <a:endParaRPr lang="en-US" smtClean="0"/>
           </a:p>
           <a:p>
             <a:pPr lvl="1"/>
@@ -2487,6 +2482,7 @@
               <a:rPr lang="en-US" smtClean="0"/>
               <a:t>Second level</a:t>
             </a:r>
+            <a:endParaRPr lang="en-US" smtClean="0"/>
           </a:p>
           <a:p>
             <a:pPr lvl="2"/>
@@ -2494,6 +2490,7 @@
               <a:rPr lang="en-US" smtClean="0"/>
               <a:t>Third level</a:t>
             </a:r>
+            <a:endParaRPr lang="en-US" smtClean="0"/>
           </a:p>
           <a:p>
             <a:pPr lvl="3"/>
@@ -2501,6 +2498,7 @@
               <a:rPr lang="en-US" smtClean="0"/>
               <a:t>Fourth level</a:t>
             </a:r>
+            <a:endParaRPr lang="en-US" smtClean="0"/>
           </a:p>
           <a:p>
             <a:pPr lvl="4"/>
@@ -2565,6 +2563,7 @@
               <a:rPr lang="en-US" smtClean="0"/>
               <a:t>Click to edit Master text styles</a:t>
             </a:r>
+            <a:endParaRPr lang="en-US" smtClean="0"/>
           </a:p>
           <a:p>
             <a:pPr lvl="1"/>
@@ -2572,6 +2571,7 @@
               <a:rPr lang="en-US" smtClean="0"/>
               <a:t>Second level</a:t>
             </a:r>
+            <a:endParaRPr lang="en-US" smtClean="0"/>
           </a:p>
           <a:p>
             <a:pPr lvl="2"/>
@@ -2579,6 +2579,7 @@
               <a:rPr lang="en-US" smtClean="0"/>
               <a:t>Third level</a:t>
             </a:r>
+            <a:endParaRPr lang="en-US" smtClean="0"/>
           </a:p>
           <a:p>
             <a:pPr lvl="3"/>
@@ -2586,6 +2587,7 @@
               <a:rPr lang="en-US" smtClean="0"/>
               <a:t>Fourth level</a:t>
             </a:r>
+            <a:endParaRPr lang="en-US" smtClean="0"/>
           </a:p>
           <a:p>
             <a:pPr lvl="4"/>
@@ -2614,7 +2616,6 @@
           <a:p>
             <a:fld id="{5BCAD085-E8A6-8845-BD4E-CB4CCA059FC4}" type="datetimeFigureOut">
               <a:rPr lang="en-US" smtClean="0"/>
-              <a:t>1/27/13</a:t>
             </a:fld>
             <a:endParaRPr lang="en-US"/>
           </a:p>
@@ -2656,18 +2657,12 @@
           <a:p>
             <a:fld id="{C1FF6DA9-008F-8B48-92A6-B652298478BF}" type="slidenum">
               <a:rPr lang="en-US" smtClean="0"/>
-              <a:t>‹#›</a:t>
             </a:fld>
             <a:endParaRPr lang="en-US"/>
           </a:p>
         </p:txBody>
       </p:sp>
     </p:spTree>
-    <p:extLst>
-      <p:ext uri="{BB962C8B-B14F-4D97-AF65-F5344CB8AC3E}">
-        <p14:creationId xmlns:p14="http://schemas.microsoft.com/office/powerpoint/2010/main" val="2782244947"/>
-      </p:ext>
-    </p:extLst>
   </p:cSld>
   <p:clrMapOvr>
     <a:masterClrMapping/>
@@ -2781,6 +2776,7 @@
               <a:rPr lang="en-US" smtClean="0"/>
               <a:t>Click to edit Master text styles</a:t>
             </a:r>
+            <a:endParaRPr lang="en-US" smtClean="0"/>
           </a:p>
         </p:txBody>
       </p:sp>
@@ -2837,6 +2833,7 @@
               <a:rPr lang="en-US" smtClean="0"/>
               <a:t>Click to edit Master text styles</a:t>
             </a:r>
+            <a:endParaRPr lang="en-US" smtClean="0"/>
           </a:p>
           <a:p>
             <a:pPr lvl="1"/>
@@ -2844,6 +2841,7 @@
               <a:rPr lang="en-US" smtClean="0"/>
               <a:t>Second level</a:t>
             </a:r>
+            <a:endParaRPr lang="en-US" smtClean="0"/>
           </a:p>
           <a:p>
             <a:pPr lvl="2"/>
@@ -2851,6 +2849,7 @@
               <a:rPr lang="en-US" smtClean="0"/>
               <a:t>Third level</a:t>
             </a:r>
+            <a:endParaRPr lang="en-US" smtClean="0"/>
           </a:p>
           <a:p>
             <a:pPr lvl="3"/>
@@ -2858,6 +2857,7 @@
               <a:rPr lang="en-US" smtClean="0"/>
               <a:t>Fourth level</a:t>
             </a:r>
+            <a:endParaRPr lang="en-US" smtClean="0"/>
           </a:p>
           <a:p>
             <a:pPr lvl="4"/>
@@ -2931,6 +2931,7 @@
               <a:rPr lang="en-US" smtClean="0"/>
               <a:t>Click to edit Master text styles</a:t>
             </a:r>
+            <a:endParaRPr lang="en-US" smtClean="0"/>
           </a:p>
         </p:txBody>
       </p:sp>
@@ -2987,6 +2988,7 @@
               <a:rPr lang="en-US" smtClean="0"/>
               <a:t>Click to edit Master text styles</a:t>
             </a:r>
+            <a:endParaRPr lang="en-US" smtClean="0"/>
           </a:p>
           <a:p>
             <a:pPr lvl="1"/>
@@ -2994,6 +2996,7 @@
               <a:rPr lang="en-US" smtClean="0"/>
               <a:t>Second level</a:t>
             </a:r>
+            <a:endParaRPr lang="en-US" smtClean="0"/>
           </a:p>
           <a:p>
             <a:pPr lvl="2"/>
@@ -3001,6 +3004,7 @@
               <a:rPr lang="en-US" smtClean="0"/>
               <a:t>Third level</a:t>
             </a:r>
+            <a:endParaRPr lang="en-US" smtClean="0"/>
           </a:p>
           <a:p>
             <a:pPr lvl="3"/>
@@ -3008,6 +3012,7 @@
               <a:rPr lang="en-US" smtClean="0"/>
               <a:t>Fourth level</a:t>
             </a:r>
+            <a:endParaRPr lang="en-US" smtClean="0"/>
           </a:p>
           <a:p>
             <a:pPr lvl="4"/>
@@ -3036,7 +3041,6 @@
           <a:p>
             <a:fld id="{5BCAD085-E8A6-8845-BD4E-CB4CCA059FC4}" type="datetimeFigureOut">
               <a:rPr lang="en-US" smtClean="0"/>
-              <a:t>1/27/13</a:t>
             </a:fld>
             <a:endParaRPr lang="en-US"/>
           </a:p>
@@ -3078,18 +3082,12 @@
           <a:p>
             <a:fld id="{C1FF6DA9-008F-8B48-92A6-B652298478BF}" type="slidenum">
               <a:rPr lang="en-US" smtClean="0"/>
-              <a:t>‹#›</a:t>
             </a:fld>
             <a:endParaRPr lang="en-US"/>
           </a:p>
         </p:txBody>
       </p:sp>
     </p:spTree>
-    <p:extLst>
-      <p:ext uri="{BB962C8B-B14F-4D97-AF65-F5344CB8AC3E}">
-        <p14:creationId xmlns:p14="http://schemas.microsoft.com/office/powerpoint/2010/main" val="990158736"/>
-      </p:ext>
-    </p:extLst>
   </p:cSld>
   <p:clrMapOvr>
     <a:masterClrMapping/>
@@ -3154,7 +3152,6 @@
           <a:p>
             <a:fld id="{5BCAD085-E8A6-8845-BD4E-CB4CCA059FC4}" type="datetimeFigureOut">
               <a:rPr lang="en-US" smtClean="0"/>
-              <a:t>1/27/13</a:t>
             </a:fld>
             <a:endParaRPr lang="en-US"/>
           </a:p>
@@ -3196,18 +3193,12 @@
           <a:p>
             <a:fld id="{C1FF6DA9-008F-8B48-92A6-B652298478BF}" type="slidenum">
               <a:rPr lang="en-US" smtClean="0"/>
-              <a:t>‹#›</a:t>
             </a:fld>
             <a:endParaRPr lang="en-US"/>
           </a:p>
         </p:txBody>
       </p:sp>
     </p:spTree>
-    <p:extLst>
-      <p:ext uri="{BB962C8B-B14F-4D97-AF65-F5344CB8AC3E}">
-        <p14:creationId xmlns:p14="http://schemas.microsoft.com/office/powerpoint/2010/main" val="727027711"/>
-      </p:ext>
-    </p:extLst>
   </p:cSld>
   <p:clrMapOvr>
     <a:masterClrMapping/>
@@ -3249,7 +3240,6 @@
           <a:p>
             <a:fld id="{5BCAD085-E8A6-8845-BD4E-CB4CCA059FC4}" type="datetimeFigureOut">
               <a:rPr lang="en-US" smtClean="0"/>
-              <a:t>1/27/13</a:t>
             </a:fld>
             <a:endParaRPr lang="en-US"/>
           </a:p>
@@ -3291,18 +3281,12 @@
           <a:p>
             <a:fld id="{C1FF6DA9-008F-8B48-92A6-B652298478BF}" type="slidenum">
               <a:rPr lang="en-US" smtClean="0"/>
-              <a:t>‹#›</a:t>
             </a:fld>
             <a:endParaRPr lang="en-US"/>
           </a:p>
         </p:txBody>
       </p:sp>
     </p:spTree>
-    <p:extLst>
-      <p:ext uri="{BB962C8B-B14F-4D97-AF65-F5344CB8AC3E}">
-        <p14:creationId xmlns:p14="http://schemas.microsoft.com/office/powerpoint/2010/main" val="1212999818"/>
-      </p:ext>
-    </p:extLst>
   </p:cSld>
   <p:clrMapOvr>
     <a:masterClrMapping/>
@@ -3412,6 +3396,7 @@
               <a:rPr lang="en-US" smtClean="0"/>
               <a:t>Click to edit Master text styles</a:t>
             </a:r>
+            <a:endParaRPr lang="en-US" smtClean="0"/>
           </a:p>
           <a:p>
             <a:pPr lvl="1"/>
@@ -3419,6 +3404,7 @@
               <a:rPr lang="en-US" smtClean="0"/>
               <a:t>Second level</a:t>
             </a:r>
+            <a:endParaRPr lang="en-US" smtClean="0"/>
           </a:p>
           <a:p>
             <a:pPr lvl="2"/>
@@ -3426,6 +3412,7 @@
               <a:rPr lang="en-US" smtClean="0"/>
               <a:t>Third level</a:t>
             </a:r>
+            <a:endParaRPr lang="en-US" smtClean="0"/>
           </a:p>
           <a:p>
             <a:pPr lvl="3"/>
@@ -3433,6 +3420,7 @@
               <a:rPr lang="en-US" smtClean="0"/>
               <a:t>Fourth level</a:t>
             </a:r>
+            <a:endParaRPr lang="en-US" smtClean="0"/>
           </a:p>
           <a:p>
             <a:pPr lvl="4"/>
@@ -3506,6 +3494,7 @@
               <a:rPr lang="en-US" smtClean="0"/>
               <a:t>Click to edit Master text styles</a:t>
             </a:r>
+            <a:endParaRPr lang="en-US" smtClean="0"/>
           </a:p>
         </p:txBody>
       </p:sp>
@@ -3526,7 +3515,6 @@
           <a:p>
             <a:fld id="{5BCAD085-E8A6-8845-BD4E-CB4CCA059FC4}" type="datetimeFigureOut">
               <a:rPr lang="en-US" smtClean="0"/>
-              <a:t>1/27/13</a:t>
             </a:fld>
             <a:endParaRPr lang="en-US"/>
           </a:p>
@@ -3568,18 +3556,12 @@
           <a:p>
             <a:fld id="{C1FF6DA9-008F-8B48-92A6-B652298478BF}" type="slidenum">
               <a:rPr lang="en-US" smtClean="0"/>
-              <a:t>‹#›</a:t>
             </a:fld>
             <a:endParaRPr lang="en-US"/>
           </a:p>
         </p:txBody>
       </p:sp>
     </p:spTree>
-    <p:extLst>
-      <p:ext uri="{BB962C8B-B14F-4D97-AF65-F5344CB8AC3E}">
-        <p14:creationId xmlns:p14="http://schemas.microsoft.com/office/powerpoint/2010/main" val="1840726560"/>
-      </p:ext>
-    </p:extLst>
   </p:cSld>
   <p:clrMapOvr>
     <a:masterClrMapping/>
@@ -3759,6 +3741,7 @@
               <a:rPr lang="en-US" smtClean="0"/>
               <a:t>Click to edit Master text styles</a:t>
             </a:r>
+            <a:endParaRPr lang="en-US" smtClean="0"/>
           </a:p>
         </p:txBody>
       </p:sp>
@@ -3779,7 +3762,6 @@
           <a:p>
             <a:fld id="{5BCAD085-E8A6-8845-BD4E-CB4CCA059FC4}" type="datetimeFigureOut">
               <a:rPr lang="en-US" smtClean="0"/>
-              <a:t>1/27/13</a:t>
             </a:fld>
             <a:endParaRPr lang="en-US"/>
           </a:p>
@@ -3821,18 +3803,12 @@
           <a:p>
             <a:fld id="{C1FF6DA9-008F-8B48-92A6-B652298478BF}" type="slidenum">
               <a:rPr lang="en-US" smtClean="0"/>
-              <a:t>‹#›</a:t>
             </a:fld>
             <a:endParaRPr lang="en-US"/>
           </a:p>
         </p:txBody>
       </p:sp>
     </p:spTree>
-    <p:extLst>
-      <p:ext uri="{BB962C8B-B14F-4D97-AF65-F5344CB8AC3E}">
-        <p14:creationId xmlns:p14="http://schemas.microsoft.com/office/powerpoint/2010/main" val="3889236939"/>
-      </p:ext>
-    </p:extLst>
   </p:cSld>
   <p:clrMapOvr>
     <a:masterClrMapping/>
@@ -3925,6 +3901,7 @@
               <a:rPr lang="en-US" smtClean="0"/>
               <a:t>Click to edit Master text styles</a:t>
             </a:r>
+            <a:endParaRPr lang="en-US" smtClean="0"/>
           </a:p>
           <a:p>
             <a:pPr lvl="1"/>
@@ -3932,6 +3909,7 @@
               <a:rPr lang="en-US" smtClean="0"/>
               <a:t>Second level</a:t>
             </a:r>
+            <a:endParaRPr lang="en-US" smtClean="0"/>
           </a:p>
           <a:p>
             <a:pPr lvl="2"/>
@@ -3939,6 +3917,7 @@
               <a:rPr lang="en-US" smtClean="0"/>
               <a:t>Third level</a:t>
             </a:r>
+            <a:endParaRPr lang="en-US" smtClean="0"/>
           </a:p>
           <a:p>
             <a:pPr lvl="3"/>
@@ -3946,6 +3925,7 @@
               <a:rPr lang="en-US" smtClean="0"/>
               <a:t>Fourth level</a:t>
             </a:r>
+            <a:endParaRPr lang="en-US" smtClean="0"/>
           </a:p>
           <a:p>
             <a:pPr lvl="4"/>
@@ -3992,7 +3972,6 @@
           <a:p>
             <a:fld id="{5BCAD085-E8A6-8845-BD4E-CB4CCA059FC4}" type="datetimeFigureOut">
               <a:rPr lang="en-US" smtClean="0"/>
-              <a:t>1/27/13</a:t>
             </a:fld>
             <a:endParaRPr lang="en-US"/>
           </a:p>
@@ -4070,18 +4049,12 @@
           <a:p>
             <a:fld id="{C1FF6DA9-008F-8B48-92A6-B652298478BF}" type="slidenum">
               <a:rPr lang="en-US" smtClean="0"/>
-              <a:t>‹#›</a:t>
             </a:fld>
             <a:endParaRPr lang="en-US"/>
           </a:p>
         </p:txBody>
       </p:sp>
     </p:spTree>
-    <p:extLst>
-      <p:ext uri="{BB962C8B-B14F-4D97-AF65-F5344CB8AC3E}">
-        <p14:creationId xmlns:p14="http://schemas.microsoft.com/office/powerpoint/2010/main" val="2209977519"/>
-      </p:ext>
-    </p:extLst>
   </p:cSld>
   <p:clrMap bg1="lt1" tx1="dk1" bg2="lt2" tx2="dk2" accent1="accent1" accent2="accent2" accent3="accent3" accent4="accent4" accent5="accent5" accent6="accent6" hlink="hlink" folHlink="folHlink"/>
   <p:sldLayoutIdLst>
@@ -4119,7 +4092,7 @@
         <a:spcBef>
           <a:spcPct val="20000"/>
         </a:spcBef>
-        <a:buFont typeface="Arial"/>
+        <a:buFont typeface="Arial" panose="020B0604020202020204"/>
         <a:buChar char="•"/>
         <a:defRPr sz="3200" kern="1200">
           <a:solidFill>
@@ -4134,7 +4107,7 @@
         <a:spcBef>
           <a:spcPct val="20000"/>
         </a:spcBef>
-        <a:buFont typeface="Arial"/>
+        <a:buFont typeface="Arial" panose="020B0604020202020204"/>
         <a:buChar char="–"/>
         <a:defRPr sz="2800" kern="1200">
           <a:solidFill>
@@ -4149,7 +4122,7 @@
         <a:spcBef>
           <a:spcPct val="20000"/>
         </a:spcBef>
-        <a:buFont typeface="Arial"/>
+        <a:buFont typeface="Arial" panose="020B0604020202020204"/>
         <a:buChar char="•"/>
         <a:defRPr sz="2400" kern="1200">
           <a:solidFill>
@@ -4164,7 +4137,7 @@
         <a:spcBef>
           <a:spcPct val="20000"/>
         </a:spcBef>
-        <a:buFont typeface="Arial"/>
+        <a:buFont typeface="Arial" panose="020B0604020202020204"/>
         <a:buChar char="–"/>
         <a:defRPr sz="2000" kern="1200">
           <a:solidFill>
@@ -4179,7 +4152,7 @@
         <a:spcBef>
           <a:spcPct val="20000"/>
         </a:spcBef>
-        <a:buFont typeface="Arial"/>
+        <a:buFont typeface="Arial" panose="020B0604020202020204"/>
         <a:buChar char="»"/>
         <a:defRPr sz="2000" kern="1200">
           <a:solidFill>
@@ -4194,7 +4167,7 @@
         <a:spcBef>
           <a:spcPct val="20000"/>
         </a:spcBef>
-        <a:buFont typeface="Arial"/>
+        <a:buFont typeface="Arial" panose="020B0604020202020204"/>
         <a:buChar char="•"/>
         <a:defRPr sz="2000" kern="1200">
           <a:solidFill>
@@ -4209,7 +4182,7 @@
         <a:spcBef>
           <a:spcPct val="20000"/>
         </a:spcBef>
-        <a:buFont typeface="Arial"/>
+        <a:buFont typeface="Arial" panose="020B0604020202020204"/>
         <a:buChar char="•"/>
         <a:defRPr sz="2000" kern="1200">
           <a:solidFill>
@@ -4224,7 +4197,7 @@
         <a:spcBef>
           <a:spcPct val="20000"/>
         </a:spcBef>
-        <a:buFont typeface="Arial"/>
+        <a:buFont typeface="Arial" panose="020B0604020202020204"/>
         <a:buChar char="•"/>
         <a:defRPr sz="2000" kern="1200">
           <a:solidFill>
@@ -4239,7 +4212,7 @@
         <a:spcBef>
           <a:spcPct val="20000"/>
         </a:spcBef>
-        <a:buFont typeface="Arial"/>
+        <a:buFont typeface="Arial" panose="020B0604020202020204"/>
         <a:buChar char="•"/>
         <a:defRPr sz="2000" kern="1200">
           <a:solidFill>
@@ -4351,7 +4324,7 @@
 </file>
 
 <file path=ppt/slides/slide1.xml><?xml version="1.0" encoding="utf-8"?>
-<p:sld xmlns:a="http://schemas.openxmlformats.org/drawingml/2006/main" xmlns:p="http://schemas.openxmlformats.org/presentationml/2006/main" xmlns:r="http://schemas.openxmlformats.org/officeDocument/2006/relationships">
+<p:sld xmlns:a="http://schemas.openxmlformats.org/drawingml/2006/main" xmlns:r="http://schemas.openxmlformats.org/officeDocument/2006/relationships" xmlns:p="http://schemas.openxmlformats.org/presentationml/2006/main">
   <p:cSld>
     <p:spTree>
       <p:nvGrpSpPr>
@@ -4369,7 +4342,7 @@
           <p:nvPr/>
         </p:nvPicPr>
         <p:blipFill>
-          <a:blip r:embed="rId2"/>
+          <a:blip r:embed="rId1"/>
           <a:stretch>
             <a:fillRect/>
           </a:stretch>
@@ -4412,10 +4385,16 @@
                 <a:solidFill>
                   <a:srgbClr val="94A3B8"/>
                 </a:solidFill>
-                <a:latin typeface="Microsoft YaHei"/>
+                <a:latin typeface="微软雅黑" panose="020B0503020204020204" charset="-122"/>
               </a:rPr>
               <a:t>1/13</a:t>
             </a:r>
+            <a:endParaRPr sz="1000">
+              <a:solidFill>
+                <a:srgbClr val="94A3B8"/>
+              </a:solidFill>
+              <a:latin typeface="微软雅黑" panose="020B0503020204020204" charset="-122"/>
+            </a:endParaRPr>
           </a:p>
         </p:txBody>
       </p:sp>
@@ -4428,7 +4407,7 @@
 </file>
 
 <file path=ppt/slides/slide10.xml><?xml version="1.0" encoding="utf-8"?>
-<p:sld xmlns:a="http://schemas.openxmlformats.org/drawingml/2006/main" xmlns:p="http://schemas.openxmlformats.org/presentationml/2006/main" xmlns:r="http://schemas.openxmlformats.org/officeDocument/2006/relationships">
+<p:sld xmlns:a="http://schemas.openxmlformats.org/drawingml/2006/main" xmlns:r="http://schemas.openxmlformats.org/officeDocument/2006/relationships" xmlns:p="http://schemas.openxmlformats.org/presentationml/2006/main">
   <p:cSld>
     <p:spTree>
       <p:nvGrpSpPr>
@@ -4446,7 +4425,7 @@
           <p:nvPr/>
         </p:nvPicPr>
         <p:blipFill>
-          <a:blip r:embed="rId2"/>
+          <a:blip r:embed="rId1"/>
           <a:stretch>
             <a:fillRect/>
           </a:stretch>
@@ -4489,10 +4468,16 @@
                 <a:solidFill>
                   <a:srgbClr val="94A3B8"/>
                 </a:solidFill>
-                <a:latin typeface="Microsoft YaHei"/>
+                <a:latin typeface="微软雅黑" panose="020B0503020204020204" charset="-122"/>
               </a:rPr>
               <a:t>10/13</a:t>
             </a:r>
+            <a:endParaRPr sz="1000">
+              <a:solidFill>
+                <a:srgbClr val="94A3B8"/>
+              </a:solidFill>
+              <a:latin typeface="微软雅黑" panose="020B0503020204020204" charset="-122"/>
+            </a:endParaRPr>
           </a:p>
         </p:txBody>
       </p:sp>
@@ -4505,7 +4490,7 @@
 </file>
 
 <file path=ppt/slides/slide11.xml><?xml version="1.0" encoding="utf-8"?>
-<p:sld xmlns:a="http://schemas.openxmlformats.org/drawingml/2006/main" xmlns:p="http://schemas.openxmlformats.org/presentationml/2006/main" xmlns:r="http://schemas.openxmlformats.org/officeDocument/2006/relationships">
+<p:sld xmlns:a="http://schemas.openxmlformats.org/drawingml/2006/main" xmlns:r="http://schemas.openxmlformats.org/officeDocument/2006/relationships" xmlns:p="http://schemas.openxmlformats.org/presentationml/2006/main">
   <p:cSld>
     <p:spTree>
       <p:nvGrpSpPr>
@@ -4523,7 +4508,7 @@
           <p:nvPr/>
         </p:nvPicPr>
         <p:blipFill>
-          <a:blip r:embed="rId2"/>
+          <a:blip r:embed="rId1"/>
           <a:stretch>
             <a:fillRect/>
           </a:stretch>
@@ -4566,10 +4551,16 @@
                 <a:solidFill>
                   <a:srgbClr val="94A3B8"/>
                 </a:solidFill>
-                <a:latin typeface="Microsoft YaHei"/>
+                <a:latin typeface="微软雅黑" panose="020B0503020204020204" charset="-122"/>
               </a:rPr>
               <a:t>11/13</a:t>
             </a:r>
+            <a:endParaRPr sz="1000">
+              <a:solidFill>
+                <a:srgbClr val="94A3B8"/>
+              </a:solidFill>
+              <a:latin typeface="微软雅黑" panose="020B0503020204020204" charset="-122"/>
+            </a:endParaRPr>
           </a:p>
         </p:txBody>
       </p:sp>
@@ -4582,7 +4573,7 @@
 </file>
 
 <file path=ppt/slides/slide12.xml><?xml version="1.0" encoding="utf-8"?>
-<p:sld xmlns:a="http://schemas.openxmlformats.org/drawingml/2006/main" xmlns:p="http://schemas.openxmlformats.org/presentationml/2006/main" xmlns:r="http://schemas.openxmlformats.org/officeDocument/2006/relationships">
+<p:sld xmlns:a="http://schemas.openxmlformats.org/drawingml/2006/main" xmlns:r="http://schemas.openxmlformats.org/officeDocument/2006/relationships" xmlns:p="http://schemas.openxmlformats.org/presentationml/2006/main">
   <p:cSld>
     <p:spTree>
       <p:nvGrpSpPr>
@@ -4600,7 +4591,7 @@
           <p:nvPr/>
         </p:nvPicPr>
         <p:blipFill>
-          <a:blip r:embed="rId2"/>
+          <a:blip r:embed="rId1"/>
           <a:stretch>
             <a:fillRect/>
           </a:stretch>
@@ -4643,10 +4634,16 @@
                 <a:solidFill>
                   <a:srgbClr val="94A3B8"/>
                 </a:solidFill>
-                <a:latin typeface="Microsoft YaHei"/>
+                <a:latin typeface="微软雅黑" panose="020B0503020204020204" charset="-122"/>
               </a:rPr>
               <a:t>12/13</a:t>
             </a:r>
+            <a:endParaRPr sz="1000">
+              <a:solidFill>
+                <a:srgbClr val="94A3B8"/>
+              </a:solidFill>
+              <a:latin typeface="微软雅黑" panose="020B0503020204020204" charset="-122"/>
+            </a:endParaRPr>
           </a:p>
         </p:txBody>
       </p:sp>
@@ -4659,7 +4656,7 @@
 </file>
 
 <file path=ppt/slides/slide13.xml><?xml version="1.0" encoding="utf-8"?>
-<p:sld xmlns:a="http://schemas.openxmlformats.org/drawingml/2006/main" xmlns:p="http://schemas.openxmlformats.org/presentationml/2006/main" xmlns:r="http://schemas.openxmlformats.org/officeDocument/2006/relationships">
+<p:sld xmlns:a="http://schemas.openxmlformats.org/drawingml/2006/main" xmlns:r="http://schemas.openxmlformats.org/officeDocument/2006/relationships" xmlns:p="http://schemas.openxmlformats.org/presentationml/2006/main">
   <p:cSld>
     <p:spTree>
       <p:nvGrpSpPr>
@@ -4677,7 +4674,7 @@
           <p:nvPr/>
         </p:nvPicPr>
         <p:blipFill>
-          <a:blip r:embed="rId2"/>
+          <a:blip r:embed="rId1"/>
           <a:stretch>
             <a:fillRect/>
           </a:stretch>
@@ -4720,10 +4717,16 @@
                 <a:solidFill>
                   <a:srgbClr val="94A3B8"/>
                 </a:solidFill>
-                <a:latin typeface="Microsoft YaHei"/>
+                <a:latin typeface="微软雅黑" panose="020B0503020204020204" charset="-122"/>
               </a:rPr>
               <a:t>13/13</a:t>
             </a:r>
+            <a:endParaRPr sz="1000">
+              <a:solidFill>
+                <a:srgbClr val="94A3B8"/>
+              </a:solidFill>
+              <a:latin typeface="微软雅黑" panose="020B0503020204020204" charset="-122"/>
+            </a:endParaRPr>
           </a:p>
         </p:txBody>
       </p:sp>
@@ -4736,7 +4739,7 @@
 </file>
 
 <file path=ppt/slides/slide2.xml><?xml version="1.0" encoding="utf-8"?>
-<p:sld xmlns:a="http://schemas.openxmlformats.org/drawingml/2006/main" xmlns:p="http://schemas.openxmlformats.org/presentationml/2006/main" xmlns:r="http://schemas.openxmlformats.org/officeDocument/2006/relationships">
+<p:sld xmlns:a="http://schemas.openxmlformats.org/drawingml/2006/main" xmlns:r="http://schemas.openxmlformats.org/officeDocument/2006/relationships" xmlns:p="http://schemas.openxmlformats.org/presentationml/2006/main">
   <p:cSld>
     <p:spTree>
       <p:nvGrpSpPr>
@@ -4754,7 +4757,7 @@
           <p:nvPr/>
         </p:nvPicPr>
         <p:blipFill>
-          <a:blip r:embed="rId2"/>
+          <a:blip r:embed="rId1"/>
           <a:stretch>
             <a:fillRect/>
           </a:stretch>
@@ -4797,10 +4800,16 @@
                 <a:solidFill>
                   <a:srgbClr val="94A3B8"/>
                 </a:solidFill>
-                <a:latin typeface="Microsoft YaHei"/>
+                <a:latin typeface="微软雅黑" panose="020B0503020204020204" charset="-122"/>
               </a:rPr>
               <a:t>2/13</a:t>
             </a:r>
+            <a:endParaRPr sz="1000">
+              <a:solidFill>
+                <a:srgbClr val="94A3B8"/>
+              </a:solidFill>
+              <a:latin typeface="微软雅黑" panose="020B0503020204020204" charset="-122"/>
+            </a:endParaRPr>
           </a:p>
         </p:txBody>
       </p:sp>
@@ -4813,7 +4822,7 @@
 </file>
 
 <file path=ppt/slides/slide3.xml><?xml version="1.0" encoding="utf-8"?>
-<p:sld xmlns:a="http://schemas.openxmlformats.org/drawingml/2006/main" xmlns:p="http://schemas.openxmlformats.org/presentationml/2006/main" xmlns:r="http://schemas.openxmlformats.org/officeDocument/2006/relationships">
+<p:sld xmlns:a="http://schemas.openxmlformats.org/drawingml/2006/main" xmlns:r="http://schemas.openxmlformats.org/officeDocument/2006/relationships" xmlns:p="http://schemas.openxmlformats.org/presentationml/2006/main">
   <p:cSld>
     <p:spTree>
       <p:nvGrpSpPr>
@@ -4831,7 +4840,7 @@
           <p:nvPr/>
         </p:nvPicPr>
         <p:blipFill>
-          <a:blip r:embed="rId2"/>
+          <a:blip r:embed="rId1"/>
           <a:stretch>
             <a:fillRect/>
           </a:stretch>
@@ -4874,10 +4883,16 @@
                 <a:solidFill>
                   <a:srgbClr val="94A3B8"/>
                 </a:solidFill>
-                <a:latin typeface="Microsoft YaHei"/>
+                <a:latin typeface="微软雅黑" panose="020B0503020204020204" charset="-122"/>
               </a:rPr>
               <a:t>3/13</a:t>
             </a:r>
+            <a:endParaRPr sz="1000">
+              <a:solidFill>
+                <a:srgbClr val="94A3B8"/>
+              </a:solidFill>
+              <a:latin typeface="微软雅黑" panose="020B0503020204020204" charset="-122"/>
+            </a:endParaRPr>
           </a:p>
         </p:txBody>
       </p:sp>
@@ -4890,7 +4905,7 @@
 </file>
 
 <file path=ppt/slides/slide4.xml><?xml version="1.0" encoding="utf-8"?>
-<p:sld xmlns:a="http://schemas.openxmlformats.org/drawingml/2006/main" xmlns:p="http://schemas.openxmlformats.org/presentationml/2006/main" xmlns:r="http://schemas.openxmlformats.org/officeDocument/2006/relationships">
+<p:sld xmlns:a="http://schemas.openxmlformats.org/drawingml/2006/main" xmlns:r="http://schemas.openxmlformats.org/officeDocument/2006/relationships" xmlns:p="http://schemas.openxmlformats.org/presentationml/2006/main">
   <p:cSld>
     <p:spTree>
       <p:nvGrpSpPr>
@@ -4908,7 +4923,7 @@
           <p:nvPr/>
         </p:nvPicPr>
         <p:blipFill>
-          <a:blip r:embed="rId2"/>
+          <a:blip r:embed="rId1"/>
           <a:stretch>
             <a:fillRect/>
           </a:stretch>
@@ -4951,10 +4966,16 @@
                 <a:solidFill>
                   <a:srgbClr val="94A3B8"/>
                 </a:solidFill>
-                <a:latin typeface="Microsoft YaHei"/>
+                <a:latin typeface="微软雅黑" panose="020B0503020204020204" charset="-122"/>
               </a:rPr>
               <a:t>4/13</a:t>
             </a:r>
+            <a:endParaRPr sz="1000">
+              <a:solidFill>
+                <a:srgbClr val="94A3B8"/>
+              </a:solidFill>
+              <a:latin typeface="微软雅黑" panose="020B0503020204020204" charset="-122"/>
+            </a:endParaRPr>
           </a:p>
         </p:txBody>
       </p:sp>
@@ -4967,7 +4988,7 @@
 </file>
 
 <file path=ppt/slides/slide5.xml><?xml version="1.0" encoding="utf-8"?>
-<p:sld xmlns:a="http://schemas.openxmlformats.org/drawingml/2006/main" xmlns:p="http://schemas.openxmlformats.org/presentationml/2006/main" xmlns:r="http://schemas.openxmlformats.org/officeDocument/2006/relationships">
+<p:sld xmlns:a="http://schemas.openxmlformats.org/drawingml/2006/main" xmlns:r="http://schemas.openxmlformats.org/officeDocument/2006/relationships" xmlns:p="http://schemas.openxmlformats.org/presentationml/2006/main">
   <p:cSld>
     <p:spTree>
       <p:nvGrpSpPr>
@@ -4985,7 +5006,7 @@
           <p:nvPr/>
         </p:nvPicPr>
         <p:blipFill>
-          <a:blip r:embed="rId2"/>
+          <a:blip r:embed="rId1"/>
           <a:stretch>
             <a:fillRect/>
           </a:stretch>
@@ -5028,10 +5049,16 @@
                 <a:solidFill>
                   <a:srgbClr val="94A3B8"/>
                 </a:solidFill>
-                <a:latin typeface="Microsoft YaHei"/>
+                <a:latin typeface="微软雅黑" panose="020B0503020204020204" charset="-122"/>
               </a:rPr>
               <a:t>5/13</a:t>
             </a:r>
+            <a:endParaRPr sz="1000">
+              <a:solidFill>
+                <a:srgbClr val="94A3B8"/>
+              </a:solidFill>
+              <a:latin typeface="微软雅黑" panose="020B0503020204020204" charset="-122"/>
+            </a:endParaRPr>
           </a:p>
         </p:txBody>
       </p:sp>
@@ -5044,7 +5071,7 @@
 </file>
 
 <file path=ppt/slides/slide6.xml><?xml version="1.0" encoding="utf-8"?>
-<p:sld xmlns:a="http://schemas.openxmlformats.org/drawingml/2006/main" xmlns:p="http://schemas.openxmlformats.org/presentationml/2006/main" xmlns:r="http://schemas.openxmlformats.org/officeDocument/2006/relationships">
+<p:sld xmlns:a="http://schemas.openxmlformats.org/drawingml/2006/main" xmlns:r="http://schemas.openxmlformats.org/officeDocument/2006/relationships" xmlns:p="http://schemas.openxmlformats.org/presentationml/2006/main">
   <p:cSld>
     <p:spTree>
       <p:nvGrpSpPr>
@@ -5062,7 +5089,7 @@
           <p:nvPr/>
         </p:nvPicPr>
         <p:blipFill>
-          <a:blip r:embed="rId2"/>
+          <a:blip r:embed="rId1"/>
           <a:stretch>
             <a:fillRect/>
           </a:stretch>
@@ -5105,10 +5132,16 @@
                 <a:solidFill>
                   <a:srgbClr val="94A3B8"/>
                 </a:solidFill>
-                <a:latin typeface="Microsoft YaHei"/>
+                <a:latin typeface="微软雅黑" panose="020B0503020204020204" charset="-122"/>
               </a:rPr>
               <a:t>6/13</a:t>
             </a:r>
+            <a:endParaRPr sz="1000">
+              <a:solidFill>
+                <a:srgbClr val="94A3B8"/>
+              </a:solidFill>
+              <a:latin typeface="微软雅黑" panose="020B0503020204020204" charset="-122"/>
+            </a:endParaRPr>
           </a:p>
         </p:txBody>
       </p:sp>
@@ -5121,7 +5154,7 @@
 </file>
 
 <file path=ppt/slides/slide7.xml><?xml version="1.0" encoding="utf-8"?>
-<p:sld xmlns:a="http://schemas.openxmlformats.org/drawingml/2006/main" xmlns:p="http://schemas.openxmlformats.org/presentationml/2006/main" xmlns:r="http://schemas.openxmlformats.org/officeDocument/2006/relationships">
+<p:sld xmlns:a="http://schemas.openxmlformats.org/drawingml/2006/main" xmlns:r="http://schemas.openxmlformats.org/officeDocument/2006/relationships" xmlns:p="http://schemas.openxmlformats.org/presentationml/2006/main">
   <p:cSld>
     <p:spTree>
       <p:nvGrpSpPr>
@@ -5139,7 +5172,7 @@
           <p:nvPr/>
         </p:nvPicPr>
         <p:blipFill>
-          <a:blip r:embed="rId2"/>
+          <a:blip r:embed="rId1"/>
           <a:stretch>
             <a:fillRect/>
           </a:stretch>
@@ -5182,10 +5215,16 @@
                 <a:solidFill>
                   <a:srgbClr val="94A3B8"/>
                 </a:solidFill>
-                <a:latin typeface="Microsoft YaHei"/>
+                <a:latin typeface="微软雅黑" panose="020B0503020204020204" charset="-122"/>
               </a:rPr>
               <a:t>7/13</a:t>
             </a:r>
+            <a:endParaRPr sz="1000">
+              <a:solidFill>
+                <a:srgbClr val="94A3B8"/>
+              </a:solidFill>
+              <a:latin typeface="微软雅黑" panose="020B0503020204020204" charset="-122"/>
+            </a:endParaRPr>
           </a:p>
         </p:txBody>
       </p:sp>
@@ -5198,7 +5237,7 @@
 </file>
 
 <file path=ppt/slides/slide8.xml><?xml version="1.0" encoding="utf-8"?>
-<p:sld xmlns:a="http://schemas.openxmlformats.org/drawingml/2006/main" xmlns:p="http://schemas.openxmlformats.org/presentationml/2006/main" xmlns:r="http://schemas.openxmlformats.org/officeDocument/2006/relationships">
+<p:sld xmlns:a="http://schemas.openxmlformats.org/drawingml/2006/main" xmlns:r="http://schemas.openxmlformats.org/officeDocument/2006/relationships" xmlns:p="http://schemas.openxmlformats.org/presentationml/2006/main">
   <p:cSld>
     <p:spTree>
       <p:nvGrpSpPr>
@@ -5216,7 +5255,7 @@
           <p:nvPr/>
         </p:nvPicPr>
         <p:blipFill>
-          <a:blip r:embed="rId2"/>
+          <a:blip r:embed="rId1"/>
           <a:stretch>
             <a:fillRect/>
           </a:stretch>
@@ -5259,10 +5298,16 @@
                 <a:solidFill>
                   <a:srgbClr val="94A3B8"/>
                 </a:solidFill>
-                <a:latin typeface="Microsoft YaHei"/>
+                <a:latin typeface="微软雅黑" panose="020B0503020204020204" charset="-122"/>
               </a:rPr>
               <a:t>8/13</a:t>
             </a:r>
+            <a:endParaRPr sz="1000">
+              <a:solidFill>
+                <a:srgbClr val="94A3B8"/>
+              </a:solidFill>
+              <a:latin typeface="微软雅黑" panose="020B0503020204020204" charset="-122"/>
+            </a:endParaRPr>
           </a:p>
         </p:txBody>
       </p:sp>
@@ -5275,7 +5320,7 @@
 </file>
 
 <file path=ppt/slides/slide9.xml><?xml version="1.0" encoding="utf-8"?>
-<p:sld xmlns:a="http://schemas.openxmlformats.org/drawingml/2006/main" xmlns:p="http://schemas.openxmlformats.org/presentationml/2006/main" xmlns:r="http://schemas.openxmlformats.org/officeDocument/2006/relationships">
+<p:sld xmlns:a="http://schemas.openxmlformats.org/drawingml/2006/main" xmlns:r="http://schemas.openxmlformats.org/officeDocument/2006/relationships" xmlns:p="http://schemas.openxmlformats.org/presentationml/2006/main">
   <p:cSld>
     <p:spTree>
       <p:nvGrpSpPr>
@@ -5293,7 +5338,7 @@
           <p:nvPr/>
         </p:nvPicPr>
         <p:blipFill>
-          <a:blip r:embed="rId2"/>
+          <a:blip r:embed="rId1"/>
           <a:stretch>
             <a:fillRect/>
           </a:stretch>
@@ -5336,10 +5381,16 @@
                 <a:solidFill>
                   <a:srgbClr val="94A3B8"/>
                 </a:solidFill>
-                <a:latin typeface="Microsoft YaHei"/>
+                <a:latin typeface="微软雅黑" panose="020B0503020204020204" charset="-122"/>
               </a:rPr>
               <a:t>9/13</a:t>
             </a:r>
+            <a:endParaRPr sz="1000">
+              <a:solidFill>
+                <a:srgbClr val="94A3B8"/>
+              </a:solidFill>
+              <a:latin typeface="微软雅黑" panose="020B0503020204020204" charset="-122"/>
+            </a:endParaRPr>
           </a:p>
         </p:txBody>
       </p:sp>
@@ -5667,7 +5718,11 @@
       </a:style>
     </a:lnDef>
   </a:objectDefaults>
-  <a:extraClrSchemeLst/>
+  <a:extLst>
+    <a:ext uri="{05A4C25C-085E-4340-85A3-A5531E510DB2}">
+      <thm15:themeFamily xmlns:thm15="http://schemas.microsoft.com/office/thememl/2012/main" name="Office Theme" id="{62F939B6-93AF-4DB8-9C6B-D6C7DFDC589F}" vid="{4A3C46E8-61CC-4603-A589-7422A47A8E4A}"/>
+    </a:ext>
+  </a:extLst>
 </a:theme>
 </file>
 
@@ -5987,6 +6042,10 @@
       </a:style>
     </a:lnDef>
   </a:objectDefaults>
-  <a:extraClrSchemeLst/>
+  <a:extLst>
+    <a:ext uri="{05A4C25C-085E-4340-85A3-A5531E510DB2}">
+      <thm15:themeFamily xmlns:thm15="http://schemas.microsoft.com/office/thememl/2012/main" name="Office Theme" id="{62F939B6-93AF-4DB8-9C6B-D6C7DFDC589F}" vid="{4A3C46E8-61CC-4603-A589-7422A47A8E4A}"/>
+    </a:ext>
+  </a:extLst>
 </a:theme>
 </file>
</xml_diff>

<commit_message>
feat: regenerate 15-page contest PPT with latest data
- Cover: add public URL 171.111.219.204:8088
- Add new slide 07: LLM provider cascade (Xirang->TokenPlan->Biren->SenseNova)
- Update slide 08: 312 real bids, 8 schema fields, 15 MCP tools
- Update slide 09: PostgreSQL 312 rows, real deployment
- Update slide 12: public URL in demo proof
- Update slide 06: architecture with Biren fallback + PG 312 records
- Total 14 slides (matches PPT_SPEAKER_DECK.md 15-page structure)
</commit_message>
<xml_diff>
--- a/docs/成军台_息壤杯预赛答辩.pptx
+++ b/docs/成军台_息壤杯预赛答辩.pptx
@@ -1,28 +1,26 @@
 
 <file path=ppt/presentation.xml><?xml version="1.0" encoding="utf-8"?>
-<p:presentation xmlns:a="http://schemas.openxmlformats.org/drawingml/2006/main" xmlns:r="http://schemas.openxmlformats.org/officeDocument/2006/relationships" xmlns:p="http://schemas.openxmlformats.org/presentationml/2006/main" autoCompressPictures="0">
+<p:presentation xmlns:a="http://schemas.openxmlformats.org/drawingml/2006/main" xmlns:r="http://schemas.openxmlformats.org/officeDocument/2006/relationships" xmlns:p="http://schemas.openxmlformats.org/presentationml/2006/main" saveSubsetFonts="1" autoCompressPictures="0">
   <p:sldMasterIdLst>
     <p:sldMasterId id="2147483648" r:id="rId1"/>
   </p:sldMasterIdLst>
-  <p:notesMasterIdLst>
-    <p:notesMasterId r:id="rId4"/>
-  </p:notesMasterIdLst>
   <p:sldIdLst>
-    <p:sldId id="256" r:id="rId3"/>
-    <p:sldId id="257" r:id="rId5"/>
-    <p:sldId id="258" r:id="rId6"/>
-    <p:sldId id="259" r:id="rId7"/>
-    <p:sldId id="260" r:id="rId8"/>
-    <p:sldId id="261" r:id="rId9"/>
-    <p:sldId id="262" r:id="rId10"/>
-    <p:sldId id="263" r:id="rId11"/>
-    <p:sldId id="264" r:id="rId12"/>
-    <p:sldId id="265" r:id="rId13"/>
-    <p:sldId id="266" r:id="rId14"/>
-    <p:sldId id="267" r:id="rId15"/>
-    <p:sldId id="268" r:id="rId16"/>
+    <p:sldId id="256" r:id="rId7"/>
+    <p:sldId id="257" r:id="rId9"/>
+    <p:sldId id="258" r:id="rId10"/>
+    <p:sldId id="259" r:id="rId11"/>
+    <p:sldId id="260" r:id="rId12"/>
+    <p:sldId id="261" r:id="rId13"/>
+    <p:sldId id="262" r:id="rId14"/>
+    <p:sldId id="263" r:id="rId15"/>
+    <p:sldId id="264" r:id="rId16"/>
+    <p:sldId id="265" r:id="rId17"/>
+    <p:sldId id="266" r:id="rId18"/>
+    <p:sldId id="267" r:id="rId19"/>
+    <p:sldId id="268" r:id="rId20"/>
+    <p:sldId id="269" r:id="rId21"/>
   </p:sldIdLst>
-  <p:sldSz cx="12191365" cy="6858000" type="screen4x3"/>
+  <p:sldSz cx="12191695" cy="6858000" type="screen4x3"/>
   <p:notesSz cx="6858000" cy="9144000"/>
   <p:defaultTextStyle>
     <a:defPPr>
@@ -119,27 +117,11 @@
       </a:defRPr>
     </a:lvl9pPr>
   </p:defaultTextStyle>
-  <p:extLst>
-    <p:ext uri="{EFAFB233-063F-42B5-8137-9DF3F51BA10A}">
-      <p15:sldGuideLst xmlns:p15="http://schemas.microsoft.com/office/powerpoint/2012/main">
-        <p15:guide id="1" orient="horz" pos="2160" userDrawn="1">
-          <p15:clr>
-            <a:srgbClr val="A4A3A4"/>
-          </p15:clr>
-        </p15:guide>
-        <p15:guide id="2" pos="2880" userDrawn="1">
-          <p15:clr>
-            <a:srgbClr val="A4A3A4"/>
-          </p15:clr>
-        </p15:guide>
-      </p15:sldGuideLst>
-    </p:ext>
-  </p:extLst>
 </p:presentation>
 </file>
 
 <file path=ppt/notesMasters/notesMaster1.xml><?xml version="1.0" encoding="utf-8"?>
-<p:notesMaster xmlns:a="http://schemas.openxmlformats.org/drawingml/2006/main" xmlns:r="http://schemas.openxmlformats.org/officeDocument/2006/relationships" xmlns:p="http://schemas.openxmlformats.org/presentationml/2006/main">
+<p:notesMaster xmlns:a="http://schemas.openxmlformats.org/drawingml/2006/main" xmlns:p="http://schemas.openxmlformats.org/presentationml/2006/main" xmlns:r="http://schemas.openxmlformats.org/officeDocument/2006/relationships">
   <p:cSld>
     <p:bg>
       <p:bgRef idx="1001">
@@ -220,6 +202,7 @@
           <a:p>
             <a:fld id="{0F89C1C7-3DCD-1040-A9CF-14679D8B5DDD}" type="datetimeFigureOut">
               <a:rPr lang="en-US" smtClean="0"/>
+              <a:t>10/17/16</a:t>
             </a:fld>
             <a:endParaRPr lang="en-US"/>
           </a:p>
@@ -286,7 +269,6 @@
               <a:rPr lang="en-US" smtClean="0"/>
               <a:t>Click to edit Master text styles</a:t>
             </a:r>
-            <a:endParaRPr lang="en-US" smtClean="0"/>
           </a:p>
           <a:p>
             <a:pPr lvl="1"/>
@@ -294,7 +276,6 @@
               <a:rPr lang="en-US" smtClean="0"/>
               <a:t>Second level</a:t>
             </a:r>
-            <a:endParaRPr lang="en-US" smtClean="0"/>
           </a:p>
           <a:p>
             <a:pPr lvl="2"/>
@@ -302,7 +283,6 @@
               <a:rPr lang="en-US" smtClean="0"/>
               <a:t>Third level</a:t>
             </a:r>
-            <a:endParaRPr lang="en-US" smtClean="0"/>
           </a:p>
           <a:p>
             <a:pPr lvl="3"/>
@@ -310,7 +290,6 @@
               <a:rPr lang="en-US" smtClean="0"/>
               <a:t>Fourth level</a:t>
             </a:r>
-            <a:endParaRPr lang="en-US" smtClean="0"/>
           </a:p>
           <a:p>
             <a:pPr lvl="4"/>
@@ -382,12 +361,18 @@
           <a:p>
             <a:fld id="{BB5E49A5-4136-284D-997B-48E1D791AD67}" type="slidenum">
               <a:rPr lang="en-US" smtClean="0"/>
+              <a:t>‹#›</a:t>
             </a:fld>
             <a:endParaRPr lang="en-US"/>
           </a:p>
         </p:txBody>
       </p:sp>
     </p:spTree>
+    <p:extLst>
+      <p:ext uri="{BB962C8B-B14F-4D97-AF65-F5344CB8AC3E}">
+        <p14:creationId xmlns:p14="http://schemas.microsoft.com/office/powerpoint/2010/main" val="2623252185"/>
+      </p:ext>
+    </p:extLst>
   </p:cSld>
   <p:clrMap bg1="lt1" tx1="dk1" bg2="lt2" tx2="dk2" accent1="accent1" accent2="accent2" accent3="accent3" accent4="accent4" accent5="accent5" accent6="accent6" hlink="hlink" folHlink="folHlink"/>
   <p:notesStyle>
@@ -486,7 +471,7 @@
 </file>
 
 <file path=ppt/notesSlides/notesSlide1.xml><?xml version="1.0" encoding="utf-8"?>
-<p:notes xmlns:a="http://schemas.openxmlformats.org/drawingml/2006/main" xmlns:r="http://schemas.openxmlformats.org/officeDocument/2006/relationships" xmlns:p="http://schemas.openxmlformats.org/presentationml/2006/main">
+<p:notes xmlns:a="http://schemas.openxmlformats.org/drawingml/2006/main" xmlns:p="http://schemas.openxmlformats.org/presentationml/2006/main" xmlns:r="http://schemas.openxmlformats.org/officeDocument/2006/relationships">
   <p:cSld>
     <p:spTree>
       <p:nvGrpSpPr>
@@ -521,7 +506,7 @@
             <a:spLocks noGrp="1"/>
           </p:cNvSpPr>
           <p:nvPr>
-            <p:ph type="body" sz="quarter" idx="3"/>
+            <p:ph type="body" idx="3" sz="quarter"/>
           </p:nvPr>
         </p:nvSpPr>
         <p:spPr/>
@@ -542,7 +527,7 @@
             <a:spLocks noGrp="1"/>
           </p:cNvSpPr>
           <p:nvPr>
-            <p:ph type="sldNum" sz="quarter" idx="5"/>
+            <p:ph type="sldNum" idx="5" sz="quarter"/>
           </p:nvPr>
         </p:nvSpPr>
         <p:spPr/>
@@ -556,7 +541,7 @@
 </file>
 
 <file path=ppt/notesSlides/notesSlide10.xml><?xml version="1.0" encoding="utf-8"?>
-<p:notes xmlns:a="http://schemas.openxmlformats.org/drawingml/2006/main" xmlns:r="http://schemas.openxmlformats.org/officeDocument/2006/relationships" xmlns:p="http://schemas.openxmlformats.org/presentationml/2006/main">
+<p:notes xmlns:a="http://schemas.openxmlformats.org/drawingml/2006/main" xmlns:p="http://schemas.openxmlformats.org/presentationml/2006/main" xmlns:r="http://schemas.openxmlformats.org/officeDocument/2006/relationships">
   <p:cSld>
     <p:spTree>
       <p:nvGrpSpPr>
@@ -591,16 +576,16 @@
             <a:spLocks noGrp="1"/>
           </p:cNvSpPr>
           <p:nvPr>
-            <p:ph type="body" sz="quarter" idx="3"/>
-          </p:nvPr>
-        </p:nvSpPr>
-        <p:spPr/>
-        <p:txBody>
-          <a:bodyPr/>
-          <a:lstStyle/>
-          <a:p>
-            <a:r>
-              <a:t>先把一人成军跑通，再按 Token 与席位经营；模板与标讯越用越厚。惠民：让个体用得起、看得见交付的 AI 协作。</a:t>
+            <p:ph type="body" idx="3" sz="quarter"/>
+          </p:nvPr>
+        </p:nvSpPr>
+        <p:spPr/>
+        <p:txBody>
+          <a:bodyPr/>
+          <a:lstStyle/>
+          <a:p>
+            <a:r>
+              <a:t>五维对位：创新在 OS 形态，实用在周报与标讯成军，完整在 60 秒可走通，技术在多智能体与真数据，价值在惠民一人成军与电信政企落地。</a:t>
             </a:r>
           </a:p>
         </p:txBody>
@@ -612,7 +597,7 @@
             <a:spLocks noGrp="1"/>
           </p:cNvSpPr>
           <p:nvPr>
-            <p:ph type="sldNum" sz="quarter" idx="5"/>
+            <p:ph type="sldNum" idx="5" sz="quarter"/>
           </p:nvPr>
         </p:nvSpPr>
         <p:spPr/>
@@ -626,7 +611,7 @@
 </file>
 
 <file path=ppt/notesSlides/notesSlide11.xml><?xml version="1.0" encoding="utf-8"?>
-<p:notes xmlns:a="http://schemas.openxmlformats.org/drawingml/2006/main" xmlns:r="http://schemas.openxmlformats.org/officeDocument/2006/relationships" xmlns:p="http://schemas.openxmlformats.org/presentationml/2006/main">
+<p:notes xmlns:a="http://schemas.openxmlformats.org/drawingml/2006/main" xmlns:p="http://schemas.openxmlformats.org/presentationml/2006/main" xmlns:r="http://schemas.openxmlformats.org/officeDocument/2006/relationships">
   <p:cSld>
     <p:spTree>
       <p:nvGrpSpPr>
@@ -661,16 +646,16 @@
             <a:spLocks noGrp="1"/>
           </p:cNvSpPr>
           <p:nvPr>
-            <p:ph type="body" sz="quarter" idx="3"/>
-          </p:nvPr>
-        </p:nvSpPr>
-        <p:spPr/>
-        <p:txBody>
-          <a:bodyPr/>
-          <a:lstStyle/>
-          <a:p>
-            <a:r>
-              <a:t>提交对齐：60 秒电影级视频、本 PPT、主仓 chengjuntai-opc-xirang、评委只读账号当面提供；公网 HTTPS 与正式 Token 按审批推进。</a:t>
+            <p:ph type="body" idx="3" sz="quarter"/>
+          </p:nvPr>
+        </p:nvSpPr>
+        <p:spPr/>
+        <p:txBody>
+          <a:bodyPr/>
+          <a:lstStyle/>
+          <a:p>
+            <a:r>
+              <a:t>先把一人成军跑通，再按 Token 与席位经营；模板与标讯越用越厚。惠民：让个体用得起、看得见交付的 AI 协作。</a:t>
             </a:r>
           </a:p>
         </p:txBody>
@@ -682,7 +667,7 @@
             <a:spLocks noGrp="1"/>
           </p:cNvSpPr>
           <p:nvPr>
-            <p:ph type="sldNum" sz="quarter" idx="5"/>
+            <p:ph type="sldNum" idx="5" sz="quarter"/>
           </p:nvPr>
         </p:nvSpPr>
         <p:spPr/>
@@ -696,7 +681,7 @@
 </file>
 
 <file path=ppt/notesSlides/notesSlide12.xml><?xml version="1.0" encoding="utf-8"?>
-<p:notes xmlns:a="http://schemas.openxmlformats.org/drawingml/2006/main" xmlns:r="http://schemas.openxmlformats.org/officeDocument/2006/relationships" xmlns:p="http://schemas.openxmlformats.org/presentationml/2006/main">
+<p:notes xmlns:a="http://schemas.openxmlformats.org/drawingml/2006/main" xmlns:p="http://schemas.openxmlformats.org/presentationml/2006/main" xmlns:r="http://schemas.openxmlformats.org/officeDocument/2006/relationships">
   <p:cSld>
     <p:spTree>
       <p:nvGrpSpPr>
@@ -731,16 +716,16 @@
             <a:spLocks noGrp="1"/>
           </p:cNvSpPr>
           <p:nvPr>
-            <p:ph type="body" sz="quarter" idx="3"/>
-          </p:nvPr>
-        </p:nvSpPr>
-        <p:spPr/>
-        <p:txBody>
-          <a:bodyPr/>
-          <a:lstStyle/>
-          <a:p>
-            <a:r>
-              <a:t>预赛打穿 60 秒与材料完整；复赛加深行业模板、证据矩阵与经营数据；远景行业方案包与孵化。</a:t>
+            <p:ph type="body" idx="3" sz="quarter"/>
+          </p:nvPr>
+        </p:nvSpPr>
+        <p:spPr/>
+        <p:txBody>
+          <a:bodyPr/>
+          <a:lstStyle/>
+          <a:p>
+            <a:r>
+              <a:t>提交对齐：60 秒电影级视频、本 PPT、主仓 chengjuntai-opc-xirang、评委只读账号当面提供；公网 HTTPS 与正式 Token 按审批推进。</a:t>
             </a:r>
           </a:p>
         </p:txBody>
@@ -752,7 +737,7 @@
             <a:spLocks noGrp="1"/>
           </p:cNvSpPr>
           <p:nvPr>
-            <p:ph type="sldNum" sz="quarter" idx="5"/>
+            <p:ph type="sldNum" idx="5" sz="quarter"/>
           </p:nvPr>
         </p:nvSpPr>
         <p:spPr/>
@@ -766,7 +751,7 @@
 </file>
 
 <file path=ppt/notesSlides/notesSlide13.xml><?xml version="1.0" encoding="utf-8"?>
-<p:notes xmlns:a="http://schemas.openxmlformats.org/drawingml/2006/main" xmlns:r="http://schemas.openxmlformats.org/officeDocument/2006/relationships" xmlns:p="http://schemas.openxmlformats.org/presentationml/2006/main">
+<p:notes xmlns:a="http://schemas.openxmlformats.org/drawingml/2006/main" xmlns:p="http://schemas.openxmlformats.org/presentationml/2006/main" xmlns:r="http://schemas.openxmlformats.org/officeDocument/2006/relationships">
   <p:cSld>
     <p:spTree>
       <p:nvGrpSpPr>
@@ -801,16 +786,16 @@
             <a:spLocks noGrp="1"/>
           </p:cNvSpPr>
           <p:nvPr>
-            <p:ph type="body" sz="quarter" idx="3"/>
-          </p:nvPr>
-        </p:nvSpPr>
-        <p:spPr/>
-        <p:txBody>
-          <a:bodyPr/>
-          <a:lstStyle/>
-          <a:p>
-            <a:r>
-              <a:t>谢谢各位评委。欢迎提问，也可现在打开 Demo，点「评委 60 秒体验」自己走一遍。</a:t>
+            <p:ph type="body" idx="3" sz="quarter"/>
+          </p:nvPr>
+        </p:nvSpPr>
+        <p:spPr/>
+        <p:txBody>
+          <a:bodyPr/>
+          <a:lstStyle/>
+          <a:p>
+            <a:r>
+              <a:t>预赛打穿 60 秒与材料完整；复赛加深行业模板、证据矩阵与经营数据；远景行业方案包与孵化。</a:t>
             </a:r>
           </a:p>
         </p:txBody>
@@ -822,7 +807,7 @@
             <a:spLocks noGrp="1"/>
           </p:cNvSpPr>
           <p:nvPr>
-            <p:ph type="sldNum" sz="quarter" idx="5"/>
+            <p:ph type="sldNum" idx="5" sz="quarter"/>
           </p:nvPr>
         </p:nvSpPr>
         <p:spPr/>
@@ -835,8 +820,8 @@
 </p:notes>
 </file>
 
-<file path=ppt/notesSlides/notesSlide2.xml><?xml version="1.0" encoding="utf-8"?>
-<p:notes xmlns:a="http://schemas.openxmlformats.org/drawingml/2006/main" xmlns:r="http://schemas.openxmlformats.org/officeDocument/2006/relationships" xmlns:p="http://schemas.openxmlformats.org/presentationml/2006/main">
+<file path=ppt/notesSlides/notesSlide14.xml><?xml version="1.0" encoding="utf-8"?>
+<p:notes xmlns:a="http://schemas.openxmlformats.org/drawingml/2006/main" xmlns:p="http://schemas.openxmlformats.org/presentationml/2006/main" xmlns:r="http://schemas.openxmlformats.org/officeDocument/2006/relationships">
   <p:cSld>
     <p:spTree>
       <p:nvGrpSpPr>
@@ -871,16 +856,16 @@
             <a:spLocks noGrp="1"/>
           </p:cNvSpPr>
           <p:nvPr>
-            <p:ph type="body" sz="quarter" idx="3"/>
-          </p:nvPr>
-        </p:nvSpPr>
-        <p:spPr/>
-        <p:txBody>
-          <a:bodyPr/>
-          <a:lstStyle/>
-          <a:p>
-            <a:r>
-              <a:t>OPC 不是缺模型，是缺操作系统：目标进来，任务树、人审、产物和周报要能交付。电信政企场景里，还要把种草内容、标讯洞察和标书材料串在同一条链上。</a:t>
+            <p:ph type="body" idx="3" sz="quarter"/>
+          </p:nvPr>
+        </p:nvSpPr>
+        <p:spPr/>
+        <p:txBody>
+          <a:bodyPr/>
+          <a:lstStyle/>
+          <a:p>
+            <a:r>
+              <a:t>谢谢各位评委。欢迎提问，也可现在打开 Demo，点「评委 60 秒体验」自己走一遍。</a:t>
             </a:r>
           </a:p>
         </p:txBody>
@@ -892,7 +877,7 @@
             <a:spLocks noGrp="1"/>
           </p:cNvSpPr>
           <p:nvPr>
-            <p:ph type="sldNum" sz="quarter" idx="5"/>
+            <p:ph type="sldNum" idx="5" sz="quarter"/>
           </p:nvPr>
         </p:nvSpPr>
         <p:spPr/>
@@ -905,8 +890,8 @@
 </p:notes>
 </file>
 
-<file path=ppt/notesSlides/notesSlide3.xml><?xml version="1.0" encoding="utf-8"?>
-<p:notes xmlns:a="http://schemas.openxmlformats.org/drawingml/2006/main" xmlns:r="http://schemas.openxmlformats.org/officeDocument/2006/relationships" xmlns:p="http://schemas.openxmlformats.org/presentationml/2006/main">
+<file path=ppt/notesSlides/notesSlide2.xml><?xml version="1.0" encoding="utf-8"?>
+<p:notes xmlns:a="http://schemas.openxmlformats.org/drawingml/2006/main" xmlns:p="http://schemas.openxmlformats.org/presentationml/2006/main" xmlns:r="http://schemas.openxmlformats.org/officeDocument/2006/relationships">
   <p:cSld>
     <p:spTree>
       <p:nvGrpSpPr>
@@ -941,16 +926,16 @@
             <a:spLocks noGrp="1"/>
           </p:cNvSpPr>
           <p:nvPr>
-            <p:ph type="body" sz="quarter" idx="3"/>
-          </p:nvPr>
-        </p:nvSpPr>
-        <p:spPr/>
-        <p:txBody>
-          <a:bodyPr/>
-          <a:lstStyle/>
-          <a:p>
-            <a:r>
-              <a:t>方案：目标驱动战役 + AI 员工矩阵 + 可导出 Word。增量：内容工厂、标书工作台、真政采 NL2SQL。底座落在息壤与天翼云，赛道是惠民 AI+自选。</a:t>
+            <p:ph type="body" idx="3" sz="quarter"/>
+          </p:nvPr>
+        </p:nvSpPr>
+        <p:spPr/>
+        <p:txBody>
+          <a:bodyPr/>
+          <a:lstStyle/>
+          <a:p>
+            <a:r>
+              <a:t>OPC 不是缺模型，是缺操作系统：目标进来，任务树、人审、产物和周报要能交付。电信政企场景里，还要把种草内容、标讯洞察和标书材料串在同一条链上。</a:t>
             </a:r>
           </a:p>
         </p:txBody>
@@ -962,7 +947,7 @@
             <a:spLocks noGrp="1"/>
           </p:cNvSpPr>
           <p:nvPr>
-            <p:ph type="sldNum" sz="quarter" idx="5"/>
+            <p:ph type="sldNum" idx="5" sz="quarter"/>
           </p:nvPr>
         </p:nvSpPr>
         <p:spPr/>
@@ -975,8 +960,8 @@
 </p:notes>
 </file>
 
-<file path=ppt/notesSlides/notesSlide4.xml><?xml version="1.0" encoding="utf-8"?>
-<p:notes xmlns:a="http://schemas.openxmlformats.org/drawingml/2006/main" xmlns:r="http://schemas.openxmlformats.org/officeDocument/2006/relationships" xmlns:p="http://schemas.openxmlformats.org/presentationml/2006/main">
+<file path=ppt/notesSlides/notesSlide3.xml><?xml version="1.0" encoding="utf-8"?>
+<p:notes xmlns:a="http://schemas.openxmlformats.org/drawingml/2006/main" xmlns:p="http://schemas.openxmlformats.org/presentationml/2006/main" xmlns:r="http://schemas.openxmlformats.org/officeDocument/2006/relationships">
   <p:cSld>
     <p:spTree>
       <p:nvGrpSpPr>
@@ -1011,16 +996,16 @@
             <a:spLocks noGrp="1"/>
           </p:cNvSpPr>
           <p:nvPr>
-            <p:ph type="body" sz="quarter" idx="3"/>
-          </p:nvPr>
-        </p:nvSpPr>
-        <p:spPr/>
-        <p:txBody>
-          <a:bodyPr/>
-          <a:lstStyle/>
-          <a:p>
-            <a:r>
-              <a:t>零讲解路径：点评委体验 → 打开已完成样例 → 导出成军周报 → 再看一张问数表。评委自己点也能走通——直接打实用性与完整性。</a:t>
+            <p:ph type="body" idx="3" sz="quarter"/>
+          </p:nvPr>
+        </p:nvSpPr>
+        <p:spPr/>
+        <p:txBody>
+          <a:bodyPr/>
+          <a:lstStyle/>
+          <a:p>
+            <a:r>
+              <a:t>方案：目标驱动战役 + AI 员工矩阵 + 可导出 Word。增量：内容工厂、标书工作台、真政采 NL2SQL。底座落在息壤与天翼云，赛道是惠民 AI+自选。</a:t>
             </a:r>
           </a:p>
         </p:txBody>
@@ -1032,7 +1017,7 @@
             <a:spLocks noGrp="1"/>
           </p:cNvSpPr>
           <p:nvPr>
-            <p:ph type="sldNum" sz="quarter" idx="5"/>
+            <p:ph type="sldNum" idx="5" sz="quarter"/>
           </p:nvPr>
         </p:nvSpPr>
         <p:spPr/>
@@ -1045,8 +1030,8 @@
 </p:notes>
 </file>
 
-<file path=ppt/notesSlides/notesSlide5.xml><?xml version="1.0" encoding="utf-8"?>
-<p:notes xmlns:a="http://schemas.openxmlformats.org/drawingml/2006/main" xmlns:r="http://schemas.openxmlformats.org/officeDocument/2006/relationships" xmlns:p="http://schemas.openxmlformats.org/presentationml/2006/main">
+<file path=ppt/notesSlides/notesSlide4.xml><?xml version="1.0" encoding="utf-8"?>
+<p:notes xmlns:a="http://schemas.openxmlformats.org/drawingml/2006/main" xmlns:p="http://schemas.openxmlformats.org/presentationml/2006/main" xmlns:r="http://schemas.openxmlformats.org/officeDocument/2006/relationships">
   <p:cSld>
     <p:spTree>
       <p:nvGrpSpPr>
@@ -1081,16 +1066,16 @@
             <a:spLocks noGrp="1"/>
           </p:cNvSpPr>
           <p:nvPr>
-            <p:ph type="body" sz="quarter" idx="3"/>
-          </p:nvPr>
-        </p:nvSpPr>
-        <p:spPr/>
-        <p:txBody>
-          <a:bodyPr/>
-          <a:lstStyle/>
-          <a:p>
-            <a:r>
-              <a:t>一人输入目标，五类角色并行，产物进抽屉，可预览、可导出 Word——创新点在可验收小队，不在多聊几句。</a:t>
+            <p:ph type="body" idx="3" sz="quarter"/>
+          </p:nvPr>
+        </p:nvSpPr>
+        <p:spPr/>
+        <p:txBody>
+          <a:bodyPr/>
+          <a:lstStyle/>
+          <a:p>
+            <a:r>
+              <a:t>零讲解路径：点评委体验 → 打开已完成样例 → 导出成军周报 → 再看一张问数表。评委自己点也能走通——直接打实用性与完整性。</a:t>
             </a:r>
           </a:p>
         </p:txBody>
@@ -1102,7 +1087,7 @@
             <a:spLocks noGrp="1"/>
           </p:cNvSpPr>
           <p:nvPr>
-            <p:ph type="sldNum" sz="quarter" idx="5"/>
+            <p:ph type="sldNum" idx="5" sz="quarter"/>
           </p:nvPr>
         </p:nvSpPr>
         <p:spPr/>
@@ -1115,8 +1100,8 @@
 </p:notes>
 </file>
 
-<file path=ppt/notesSlides/notesSlide6.xml><?xml version="1.0" encoding="utf-8"?>
-<p:notes xmlns:a="http://schemas.openxmlformats.org/drawingml/2006/main" xmlns:r="http://schemas.openxmlformats.org/officeDocument/2006/relationships" xmlns:p="http://schemas.openxmlformats.org/presentationml/2006/main">
+<file path=ppt/notesSlides/notesSlide5.xml><?xml version="1.0" encoding="utf-8"?>
+<p:notes xmlns:a="http://schemas.openxmlformats.org/drawingml/2006/main" xmlns:p="http://schemas.openxmlformats.org/presentationml/2006/main" xmlns:r="http://schemas.openxmlformats.org/officeDocument/2006/relationships">
   <p:cSld>
     <p:spTree>
       <p:nvGrpSpPr>
@@ -1151,16 +1136,16 @@
             <a:spLocks noGrp="1"/>
           </p:cNvSpPr>
           <p:nvPr>
-            <p:ph type="body" sz="quarter" idx="3"/>
-          </p:nvPr>
-        </p:nvSpPr>
-        <p:spPr/>
-        <p:txBody>
-          <a:bodyPr/>
-          <a:lstStyle/>
-          <a:p>
-            <a:r>
-              <a:t>工程底座：Web 看板、司令 Agent、战役状态机、多 Agent、息壤 LLM、NL2SQL 与标讯库。无 Key 明确失败，禁止静默 mock。</a:t>
+            <p:ph type="body" idx="3" sz="quarter"/>
+          </p:nvPr>
+        </p:nvSpPr>
+        <p:spPr/>
+        <p:txBody>
+          <a:bodyPr/>
+          <a:lstStyle/>
+          <a:p>
+            <a:r>
+              <a:t>一人输入目标，五类角色并行，产物进抽屉，可预览、可导出 Word——创新点在可验收小队，不在多聊几句。</a:t>
             </a:r>
           </a:p>
         </p:txBody>
@@ -1172,7 +1157,7 @@
             <a:spLocks noGrp="1"/>
           </p:cNvSpPr>
           <p:nvPr>
-            <p:ph type="sldNum" sz="quarter" idx="5"/>
+            <p:ph type="sldNum" idx="5" sz="quarter"/>
           </p:nvPr>
         </p:nvSpPr>
         <p:spPr/>
@@ -1185,8 +1170,8 @@
 </p:notes>
 </file>
 
-<file path=ppt/notesSlides/notesSlide7.xml><?xml version="1.0" encoding="utf-8"?>
-<p:notes xmlns:a="http://schemas.openxmlformats.org/drawingml/2006/main" xmlns:r="http://schemas.openxmlformats.org/officeDocument/2006/relationships" xmlns:p="http://schemas.openxmlformats.org/presentationml/2006/main">
+<file path=ppt/notesSlides/notesSlide6.xml><?xml version="1.0" encoding="utf-8"?>
+<p:notes xmlns:a="http://schemas.openxmlformats.org/drawingml/2006/main" xmlns:p="http://schemas.openxmlformats.org/presentationml/2006/main" xmlns:r="http://schemas.openxmlformats.org/officeDocument/2006/relationships">
   <p:cSld>
     <p:spTree>
       <p:nvGrpSpPr>
@@ -1221,16 +1206,16 @@
             <a:spLocks noGrp="1"/>
           </p:cNvSpPr>
           <p:nvPr>
-            <p:ph type="body" sz="quarter" idx="3"/>
-          </p:nvPr>
-        </p:nvSpPr>
-        <p:spPr/>
-        <p:txBody>
-          <a:bodyPr/>
-          <a:lstStyle/>
-          <a:p>
-            <a:r>
-              <a:t>浙江政采公开标讯约 382 条入库可刷新；样例周包种子化保证 60 秒可走通；产物可预览、可导出 Word、可推入标书知识库。</a:t>
+            <p:ph type="body" idx="3" sz="quarter"/>
+          </p:nvPr>
+        </p:nvSpPr>
+        <p:spPr/>
+        <p:txBody>
+          <a:bodyPr/>
+          <a:lstStyle/>
+          <a:p>
+            <a:r>
+              <a:t>工程底座：Web 看板、司令 Agent、战役状态机、多 Agent、息壤 LLM、NL2SQL 与标讯库。无 Key 明确失败，禁止静默 mock。</a:t>
             </a:r>
           </a:p>
         </p:txBody>
@@ -1242,7 +1227,7 @@
             <a:spLocks noGrp="1"/>
           </p:cNvSpPr>
           <p:nvPr>
-            <p:ph type="sldNum" sz="quarter" idx="5"/>
+            <p:ph type="sldNum" idx="5" sz="quarter"/>
           </p:nvPr>
         </p:nvSpPr>
         <p:spPr/>
@@ -1255,8 +1240,8 @@
 </p:notes>
 </file>
 
-<file path=ppt/notesSlides/notesSlide8.xml><?xml version="1.0" encoding="utf-8"?>
-<p:notes xmlns:a="http://schemas.openxmlformats.org/drawingml/2006/main" xmlns:r="http://schemas.openxmlformats.org/officeDocument/2006/relationships" xmlns:p="http://schemas.openxmlformats.org/presentationml/2006/main">
+<file path=ppt/notesSlides/notesSlide7.xml><?xml version="1.0" encoding="utf-8"?>
+<p:notes xmlns:a="http://schemas.openxmlformats.org/drawingml/2006/main" xmlns:p="http://schemas.openxmlformats.org/presentationml/2006/main" xmlns:r="http://schemas.openxmlformats.org/officeDocument/2006/relationships">
   <p:cSld>
     <p:spTree>
       <p:nvGrpSpPr>
@@ -1291,16 +1276,16 @@
             <a:spLocks noGrp="1"/>
           </p:cNvSpPr>
           <p:nvPr>
-            <p:ph type="body" sz="quarter" idx="3"/>
-          </p:nvPr>
-        </p:nvSpPr>
-        <p:spPr/>
-        <p:txBody>
-          <a:bodyPr/>
-          <a:lstStyle/>
-          <a:p>
-            <a:r>
-              <a:t>标书材料工作台：粘贴招标文本 → 要求拆解 → 生成证据矩阵 → 导出 Word 附卷。电信员工熟悉的政企场景，OPC 也能成军。</a:t>
+            <p:ph type="body" idx="3" sz="quarter"/>
+          </p:nvPr>
+        </p:nvSpPr>
+        <p:spPr/>
+        <p:txBody>
+          <a:bodyPr/>
+          <a:lstStyle/>
+          <a:p>
+            <a:r>
+              <a:t>双轨就绪：竞赛 Token 到手切 primary；之前用过渡模型也能真实 E2E。没有 Key 绝不假装成功——这是技术诚信，也是评委信任。</a:t>
             </a:r>
           </a:p>
         </p:txBody>
@@ -1312,7 +1297,7 @@
             <a:spLocks noGrp="1"/>
           </p:cNvSpPr>
           <p:nvPr>
-            <p:ph type="sldNum" sz="quarter" idx="5"/>
+            <p:ph type="sldNum" idx="5" sz="quarter"/>
           </p:nvPr>
         </p:nvSpPr>
         <p:spPr/>
@@ -1325,8 +1310,8 @@
 </p:notes>
 </file>
 
-<file path=ppt/notesSlides/notesSlide9.xml><?xml version="1.0" encoding="utf-8"?>
-<p:notes xmlns:a="http://schemas.openxmlformats.org/drawingml/2006/main" xmlns:r="http://schemas.openxmlformats.org/officeDocument/2006/relationships" xmlns:p="http://schemas.openxmlformats.org/presentationml/2006/main">
+<file path=ppt/notesSlides/notesSlide8.xml><?xml version="1.0" encoding="utf-8"?>
+<p:notes xmlns:a="http://schemas.openxmlformats.org/drawingml/2006/main" xmlns:p="http://schemas.openxmlformats.org/presentationml/2006/main" xmlns:r="http://schemas.openxmlformats.org/officeDocument/2006/relationships">
   <p:cSld>
     <p:spTree>
       <p:nvGrpSpPr>
@@ -1361,16 +1346,16 @@
             <a:spLocks noGrp="1"/>
           </p:cNvSpPr>
           <p:nvPr>
-            <p:ph type="body" sz="quarter" idx="3"/>
-          </p:nvPr>
-        </p:nvSpPr>
-        <p:spPr/>
-        <p:txBody>
-          <a:bodyPr/>
-          <a:lstStyle/>
-          <a:p>
-            <a:r>
-              <a:t>五维对位：创新在 OS 形态，实用在周报与标讯成军，完整在 60 秒可走通，技术在多智能体与真数据，价值在惠民一人成军与电信政企落地。</a:t>
+            <p:ph type="body" idx="3" sz="quarter"/>
+          </p:nvPr>
+        </p:nvSpPr>
+        <p:spPr/>
+        <p:txBody>
+          <a:bodyPr/>
+          <a:lstStyle/>
+          <a:p>
+            <a:r>
+              <a:t>312条浙江政采真实标讯入库 PostgreSQL；15个 MCP 工具；样例周包种子化保证 60 秒可走通；产物可预览、可导出 Word。</a:t>
             </a:r>
           </a:p>
         </p:txBody>
@@ -1382,7 +1367,77 @@
             <a:spLocks noGrp="1"/>
           </p:cNvSpPr>
           <p:nvPr>
-            <p:ph type="sldNum" sz="quarter" idx="5"/>
+            <p:ph type="sldNum" idx="5" sz="quarter"/>
+          </p:nvPr>
+        </p:nvSpPr>
+        <p:spPr/>
+      </p:sp>
+    </p:spTree>
+  </p:cSld>
+  <p:clrMapOvr>
+    <a:masterClrMapping/>
+  </p:clrMapOvr>
+</p:notes>
+</file>
+
+<file path=ppt/notesSlides/notesSlide9.xml><?xml version="1.0" encoding="utf-8"?>
+<p:notes xmlns:a="http://schemas.openxmlformats.org/drawingml/2006/main" xmlns:p="http://schemas.openxmlformats.org/presentationml/2006/main" xmlns:r="http://schemas.openxmlformats.org/officeDocument/2006/relationships">
+  <p:cSld>
+    <p:spTree>
+      <p:nvGrpSpPr>
+        <p:cNvPr id="1" name=""/>
+        <p:cNvGrpSpPr/>
+        <p:nvPr/>
+      </p:nvGrpSpPr>
+      <p:grpSpPr>
+        <a:xfrm>
+          <a:off x="0" y="0"/>
+          <a:ext cx="0" cy="0"/>
+          <a:chOff x="0" y="0"/>
+          <a:chExt cx="0" cy="0"/>
+        </a:xfrm>
+      </p:grpSpPr>
+      <p:sp>
+        <p:nvSpPr>
+          <p:cNvPr id="2" name="Slide Image Placeholder 1"/>
+          <p:cNvSpPr>
+            <a:spLocks noGrp="1"/>
+          </p:cNvSpPr>
+          <p:nvPr>
+            <p:ph type="sldImg" idx="2"/>
+          </p:nvPr>
+        </p:nvSpPr>
+        <p:spPr/>
+      </p:sp>
+      <p:sp>
+        <p:nvSpPr>
+          <p:cNvPr id="3" name="Notes Placeholder 2"/>
+          <p:cNvSpPr>
+            <a:spLocks noGrp="1"/>
+          </p:cNvSpPr>
+          <p:nvPr>
+            <p:ph type="body" idx="3" sz="quarter"/>
+          </p:nvPr>
+        </p:nvSpPr>
+        <p:spPr/>
+        <p:txBody>
+          <a:bodyPr/>
+          <a:lstStyle/>
+          <a:p>
+            <a:r>
+              <a:t>标书材料工作台：粘贴招标文本 → 要求拆解 → 生成证据矩阵 → 导出 Word 附卷。电信员工熟悉的政企场景，OPC 也能成军。</a:t>
+            </a:r>
+          </a:p>
+        </p:txBody>
+      </p:sp>
+      <p:sp>
+        <p:nvSpPr>
+          <p:cNvPr id="4" name="Slide Number Placeholder 3"/>
+          <p:cNvSpPr>
+            <a:spLocks noGrp="1"/>
+          </p:cNvSpPr>
+          <p:nvPr>
+            <p:ph type="sldNum" idx="5" sz="quarter"/>
           </p:nvPr>
         </p:nvSpPr>
         <p:spPr/>
@@ -1576,6 +1631,7 @@
           <a:p>
             <a:fld id="{5BCAD085-E8A6-8845-BD4E-CB4CCA059FC4}" type="datetimeFigureOut">
               <a:rPr lang="en-US" smtClean="0"/>
+              <a:t>1/27/13</a:t>
             </a:fld>
             <a:endParaRPr lang="en-US"/>
           </a:p>
@@ -1617,12 +1673,18 @@
           <a:p>
             <a:fld id="{C1FF6DA9-008F-8B48-92A6-B652298478BF}" type="slidenum">
               <a:rPr lang="en-US" smtClean="0"/>
+              <a:t>‹#›</a:t>
             </a:fld>
             <a:endParaRPr lang="en-US"/>
           </a:p>
         </p:txBody>
       </p:sp>
     </p:spTree>
+    <p:extLst>
+      <p:ext uri="{BB962C8B-B14F-4D97-AF65-F5344CB8AC3E}">
+        <p14:creationId xmlns:p14="http://schemas.microsoft.com/office/powerpoint/2010/main" val="3168075583"/>
+      </p:ext>
+    </p:extLst>
   </p:cSld>
   <p:clrMapOvr>
     <a:masterClrMapping/>
@@ -1690,7 +1752,6 @@
               <a:rPr lang="en-US" smtClean="0"/>
               <a:t>Click to edit Master text styles</a:t>
             </a:r>
-            <a:endParaRPr lang="en-US" smtClean="0"/>
           </a:p>
           <a:p>
             <a:pPr lvl="1"/>
@@ -1698,7 +1759,6 @@
               <a:rPr lang="en-US" smtClean="0"/>
               <a:t>Second level</a:t>
             </a:r>
-            <a:endParaRPr lang="en-US" smtClean="0"/>
           </a:p>
           <a:p>
             <a:pPr lvl="2"/>
@@ -1706,7 +1766,6 @@
               <a:rPr lang="en-US" smtClean="0"/>
               <a:t>Third level</a:t>
             </a:r>
-            <a:endParaRPr lang="en-US" smtClean="0"/>
           </a:p>
           <a:p>
             <a:pPr lvl="3"/>
@@ -1714,7 +1773,6 @@
               <a:rPr lang="en-US" smtClean="0"/>
               <a:t>Fourth level</a:t>
             </a:r>
-            <a:endParaRPr lang="en-US" smtClean="0"/>
           </a:p>
           <a:p>
             <a:pPr lvl="4"/>
@@ -1743,6 +1801,7 @@
           <a:p>
             <a:fld id="{5BCAD085-E8A6-8845-BD4E-CB4CCA059FC4}" type="datetimeFigureOut">
               <a:rPr lang="en-US" smtClean="0"/>
+              <a:t>1/27/13</a:t>
             </a:fld>
             <a:endParaRPr lang="en-US"/>
           </a:p>
@@ -1784,12 +1843,18 @@
           <a:p>
             <a:fld id="{C1FF6DA9-008F-8B48-92A6-B652298478BF}" type="slidenum">
               <a:rPr lang="en-US" smtClean="0"/>
+              <a:t>‹#›</a:t>
             </a:fld>
             <a:endParaRPr lang="en-US"/>
           </a:p>
         </p:txBody>
       </p:sp>
     </p:spTree>
+    <p:extLst>
+      <p:ext uri="{BB962C8B-B14F-4D97-AF65-F5344CB8AC3E}">
+        <p14:creationId xmlns:p14="http://schemas.microsoft.com/office/powerpoint/2010/main" val="2910927964"/>
+      </p:ext>
+    </p:extLst>
   </p:cSld>
   <p:clrMapOvr>
     <a:masterClrMapping/>
@@ -1867,7 +1932,6 @@
               <a:rPr lang="en-US" smtClean="0"/>
               <a:t>Click to edit Master text styles</a:t>
             </a:r>
-            <a:endParaRPr lang="en-US" smtClean="0"/>
           </a:p>
           <a:p>
             <a:pPr lvl="1"/>
@@ -1875,7 +1939,6 @@
               <a:rPr lang="en-US" smtClean="0"/>
               <a:t>Second level</a:t>
             </a:r>
-            <a:endParaRPr lang="en-US" smtClean="0"/>
           </a:p>
           <a:p>
             <a:pPr lvl="2"/>
@@ -1883,7 +1946,6 @@
               <a:rPr lang="en-US" smtClean="0"/>
               <a:t>Third level</a:t>
             </a:r>
-            <a:endParaRPr lang="en-US" smtClean="0"/>
           </a:p>
           <a:p>
             <a:pPr lvl="3"/>
@@ -1891,7 +1953,6 @@
               <a:rPr lang="en-US" smtClean="0"/>
               <a:t>Fourth level</a:t>
             </a:r>
-            <a:endParaRPr lang="en-US" smtClean="0"/>
           </a:p>
           <a:p>
             <a:pPr lvl="4"/>
@@ -1920,6 +1981,7 @@
           <a:p>
             <a:fld id="{5BCAD085-E8A6-8845-BD4E-CB4CCA059FC4}" type="datetimeFigureOut">
               <a:rPr lang="en-US" smtClean="0"/>
+              <a:t>1/27/13</a:t>
             </a:fld>
             <a:endParaRPr lang="en-US"/>
           </a:p>
@@ -1961,12 +2023,18 @@
           <a:p>
             <a:fld id="{C1FF6DA9-008F-8B48-92A6-B652298478BF}" type="slidenum">
               <a:rPr lang="en-US" smtClean="0"/>
+              <a:t>‹#›</a:t>
             </a:fld>
             <a:endParaRPr lang="en-US"/>
           </a:p>
         </p:txBody>
       </p:sp>
     </p:spTree>
+    <p:extLst>
+      <p:ext uri="{BB962C8B-B14F-4D97-AF65-F5344CB8AC3E}">
+        <p14:creationId xmlns:p14="http://schemas.microsoft.com/office/powerpoint/2010/main" val="3612223792"/>
+      </p:ext>
+    </p:extLst>
   </p:cSld>
   <p:clrMapOvr>
     <a:masterClrMapping/>
@@ -2034,7 +2102,6 @@
               <a:rPr lang="en-US" smtClean="0"/>
               <a:t>Click to edit Master text styles</a:t>
             </a:r>
-            <a:endParaRPr lang="en-US" smtClean="0"/>
           </a:p>
           <a:p>
             <a:pPr lvl="1"/>
@@ -2042,7 +2109,6 @@
               <a:rPr lang="en-US" smtClean="0"/>
               <a:t>Second level</a:t>
             </a:r>
-            <a:endParaRPr lang="en-US" smtClean="0"/>
           </a:p>
           <a:p>
             <a:pPr lvl="2"/>
@@ -2050,7 +2116,6 @@
               <a:rPr lang="en-US" smtClean="0"/>
               <a:t>Third level</a:t>
             </a:r>
-            <a:endParaRPr lang="en-US" smtClean="0"/>
           </a:p>
           <a:p>
             <a:pPr lvl="3"/>
@@ -2058,7 +2123,6 @@
               <a:rPr lang="en-US" smtClean="0"/>
               <a:t>Fourth level</a:t>
             </a:r>
-            <a:endParaRPr lang="en-US" smtClean="0"/>
           </a:p>
           <a:p>
             <a:pPr lvl="4"/>
@@ -2087,6 +2151,7 @@
           <a:p>
             <a:fld id="{5BCAD085-E8A6-8845-BD4E-CB4CCA059FC4}" type="datetimeFigureOut">
               <a:rPr lang="en-US" smtClean="0"/>
+              <a:t>1/27/13</a:t>
             </a:fld>
             <a:endParaRPr lang="en-US"/>
           </a:p>
@@ -2128,12 +2193,18 @@
           <a:p>
             <a:fld id="{C1FF6DA9-008F-8B48-92A6-B652298478BF}" type="slidenum">
               <a:rPr lang="en-US" smtClean="0"/>
+              <a:t>‹#›</a:t>
             </a:fld>
             <a:endParaRPr lang="en-US"/>
           </a:p>
         </p:txBody>
       </p:sp>
     </p:spTree>
+    <p:extLst>
+      <p:ext uri="{BB962C8B-B14F-4D97-AF65-F5344CB8AC3E}">
+        <p14:creationId xmlns:p14="http://schemas.microsoft.com/office/powerpoint/2010/main" val="2614314258"/>
+      </p:ext>
+    </p:extLst>
   </p:cSld>
   <p:clrMapOvr>
     <a:masterClrMapping/>
@@ -2306,7 +2377,6 @@
               <a:rPr lang="en-US" smtClean="0"/>
               <a:t>Click to edit Master text styles</a:t>
             </a:r>
-            <a:endParaRPr lang="en-US" smtClean="0"/>
           </a:p>
         </p:txBody>
       </p:sp>
@@ -2327,6 +2397,7 @@
           <a:p>
             <a:fld id="{5BCAD085-E8A6-8845-BD4E-CB4CCA059FC4}" type="datetimeFigureOut">
               <a:rPr lang="en-US" smtClean="0"/>
+              <a:t>1/27/13</a:t>
             </a:fld>
             <a:endParaRPr lang="en-US"/>
           </a:p>
@@ -2368,12 +2439,18 @@
           <a:p>
             <a:fld id="{C1FF6DA9-008F-8B48-92A6-B652298478BF}" type="slidenum">
               <a:rPr lang="en-US" smtClean="0"/>
+              <a:t>‹#›</a:t>
             </a:fld>
             <a:endParaRPr lang="en-US"/>
           </a:p>
         </p:txBody>
       </p:sp>
     </p:spTree>
+    <p:extLst>
+      <p:ext uri="{BB962C8B-B14F-4D97-AF65-F5344CB8AC3E}">
+        <p14:creationId xmlns:p14="http://schemas.microsoft.com/office/powerpoint/2010/main" val="960648375"/>
+      </p:ext>
+    </p:extLst>
   </p:cSld>
   <p:clrMapOvr>
     <a:masterClrMapping/>
@@ -2474,7 +2551,6 @@
               <a:rPr lang="en-US" smtClean="0"/>
               <a:t>Click to edit Master text styles</a:t>
             </a:r>
-            <a:endParaRPr lang="en-US" smtClean="0"/>
           </a:p>
           <a:p>
             <a:pPr lvl="1"/>
@@ -2482,7 +2558,6 @@
               <a:rPr lang="en-US" smtClean="0"/>
               <a:t>Second level</a:t>
             </a:r>
-            <a:endParaRPr lang="en-US" smtClean="0"/>
           </a:p>
           <a:p>
             <a:pPr lvl="2"/>
@@ -2490,7 +2565,6 @@
               <a:rPr lang="en-US" smtClean="0"/>
               <a:t>Third level</a:t>
             </a:r>
-            <a:endParaRPr lang="en-US" smtClean="0"/>
           </a:p>
           <a:p>
             <a:pPr lvl="3"/>
@@ -2498,7 +2572,6 @@
               <a:rPr lang="en-US" smtClean="0"/>
               <a:t>Fourth level</a:t>
             </a:r>
-            <a:endParaRPr lang="en-US" smtClean="0"/>
           </a:p>
           <a:p>
             <a:pPr lvl="4"/>
@@ -2563,7 +2636,6 @@
               <a:rPr lang="en-US" smtClean="0"/>
               <a:t>Click to edit Master text styles</a:t>
             </a:r>
-            <a:endParaRPr lang="en-US" smtClean="0"/>
           </a:p>
           <a:p>
             <a:pPr lvl="1"/>
@@ -2571,7 +2643,6 @@
               <a:rPr lang="en-US" smtClean="0"/>
               <a:t>Second level</a:t>
             </a:r>
-            <a:endParaRPr lang="en-US" smtClean="0"/>
           </a:p>
           <a:p>
             <a:pPr lvl="2"/>
@@ -2579,7 +2650,6 @@
               <a:rPr lang="en-US" smtClean="0"/>
               <a:t>Third level</a:t>
             </a:r>
-            <a:endParaRPr lang="en-US" smtClean="0"/>
           </a:p>
           <a:p>
             <a:pPr lvl="3"/>
@@ -2587,7 +2657,6 @@
               <a:rPr lang="en-US" smtClean="0"/>
               <a:t>Fourth level</a:t>
             </a:r>
-            <a:endParaRPr lang="en-US" smtClean="0"/>
           </a:p>
           <a:p>
             <a:pPr lvl="4"/>
@@ -2616,6 +2685,7 @@
           <a:p>
             <a:fld id="{5BCAD085-E8A6-8845-BD4E-CB4CCA059FC4}" type="datetimeFigureOut">
               <a:rPr lang="en-US" smtClean="0"/>
+              <a:t>1/27/13</a:t>
             </a:fld>
             <a:endParaRPr lang="en-US"/>
           </a:p>
@@ -2657,12 +2727,18 @@
           <a:p>
             <a:fld id="{C1FF6DA9-008F-8B48-92A6-B652298478BF}" type="slidenum">
               <a:rPr lang="en-US" smtClean="0"/>
+              <a:t>‹#›</a:t>
             </a:fld>
             <a:endParaRPr lang="en-US"/>
           </a:p>
         </p:txBody>
       </p:sp>
     </p:spTree>
+    <p:extLst>
+      <p:ext uri="{BB962C8B-B14F-4D97-AF65-F5344CB8AC3E}">
+        <p14:creationId xmlns:p14="http://schemas.microsoft.com/office/powerpoint/2010/main" val="2782244947"/>
+      </p:ext>
+    </p:extLst>
   </p:cSld>
   <p:clrMapOvr>
     <a:masterClrMapping/>
@@ -2776,7 +2852,6 @@
               <a:rPr lang="en-US" smtClean="0"/>
               <a:t>Click to edit Master text styles</a:t>
             </a:r>
-            <a:endParaRPr lang="en-US" smtClean="0"/>
           </a:p>
         </p:txBody>
       </p:sp>
@@ -2833,7 +2908,6 @@
               <a:rPr lang="en-US" smtClean="0"/>
               <a:t>Click to edit Master text styles</a:t>
             </a:r>
-            <a:endParaRPr lang="en-US" smtClean="0"/>
           </a:p>
           <a:p>
             <a:pPr lvl="1"/>
@@ -2841,7 +2915,6 @@
               <a:rPr lang="en-US" smtClean="0"/>
               <a:t>Second level</a:t>
             </a:r>
-            <a:endParaRPr lang="en-US" smtClean="0"/>
           </a:p>
           <a:p>
             <a:pPr lvl="2"/>
@@ -2849,7 +2922,6 @@
               <a:rPr lang="en-US" smtClean="0"/>
               <a:t>Third level</a:t>
             </a:r>
-            <a:endParaRPr lang="en-US" smtClean="0"/>
           </a:p>
           <a:p>
             <a:pPr lvl="3"/>
@@ -2857,7 +2929,6 @@
               <a:rPr lang="en-US" smtClean="0"/>
               <a:t>Fourth level</a:t>
             </a:r>
-            <a:endParaRPr lang="en-US" smtClean="0"/>
           </a:p>
           <a:p>
             <a:pPr lvl="4"/>
@@ -2931,7 +3002,6 @@
               <a:rPr lang="en-US" smtClean="0"/>
               <a:t>Click to edit Master text styles</a:t>
             </a:r>
-            <a:endParaRPr lang="en-US" smtClean="0"/>
           </a:p>
         </p:txBody>
       </p:sp>
@@ -2988,7 +3058,6 @@
               <a:rPr lang="en-US" smtClean="0"/>
               <a:t>Click to edit Master text styles</a:t>
             </a:r>
-            <a:endParaRPr lang="en-US" smtClean="0"/>
           </a:p>
           <a:p>
             <a:pPr lvl="1"/>
@@ -2996,7 +3065,6 @@
               <a:rPr lang="en-US" smtClean="0"/>
               <a:t>Second level</a:t>
             </a:r>
-            <a:endParaRPr lang="en-US" smtClean="0"/>
           </a:p>
           <a:p>
             <a:pPr lvl="2"/>
@@ -3004,7 +3072,6 @@
               <a:rPr lang="en-US" smtClean="0"/>
               <a:t>Third level</a:t>
             </a:r>
-            <a:endParaRPr lang="en-US" smtClean="0"/>
           </a:p>
           <a:p>
             <a:pPr lvl="3"/>
@@ -3012,7 +3079,6 @@
               <a:rPr lang="en-US" smtClean="0"/>
               <a:t>Fourth level</a:t>
             </a:r>
-            <a:endParaRPr lang="en-US" smtClean="0"/>
           </a:p>
           <a:p>
             <a:pPr lvl="4"/>
@@ -3041,6 +3107,7 @@
           <a:p>
             <a:fld id="{5BCAD085-E8A6-8845-BD4E-CB4CCA059FC4}" type="datetimeFigureOut">
               <a:rPr lang="en-US" smtClean="0"/>
+              <a:t>1/27/13</a:t>
             </a:fld>
             <a:endParaRPr lang="en-US"/>
           </a:p>
@@ -3082,12 +3149,18 @@
           <a:p>
             <a:fld id="{C1FF6DA9-008F-8B48-92A6-B652298478BF}" type="slidenum">
               <a:rPr lang="en-US" smtClean="0"/>
+              <a:t>‹#›</a:t>
             </a:fld>
             <a:endParaRPr lang="en-US"/>
           </a:p>
         </p:txBody>
       </p:sp>
     </p:spTree>
+    <p:extLst>
+      <p:ext uri="{BB962C8B-B14F-4D97-AF65-F5344CB8AC3E}">
+        <p14:creationId xmlns:p14="http://schemas.microsoft.com/office/powerpoint/2010/main" val="990158736"/>
+      </p:ext>
+    </p:extLst>
   </p:cSld>
   <p:clrMapOvr>
     <a:masterClrMapping/>
@@ -3152,6 +3225,7 @@
           <a:p>
             <a:fld id="{5BCAD085-E8A6-8845-BD4E-CB4CCA059FC4}" type="datetimeFigureOut">
               <a:rPr lang="en-US" smtClean="0"/>
+              <a:t>1/27/13</a:t>
             </a:fld>
             <a:endParaRPr lang="en-US"/>
           </a:p>
@@ -3193,12 +3267,18 @@
           <a:p>
             <a:fld id="{C1FF6DA9-008F-8B48-92A6-B652298478BF}" type="slidenum">
               <a:rPr lang="en-US" smtClean="0"/>
+              <a:t>‹#›</a:t>
             </a:fld>
             <a:endParaRPr lang="en-US"/>
           </a:p>
         </p:txBody>
       </p:sp>
     </p:spTree>
+    <p:extLst>
+      <p:ext uri="{BB962C8B-B14F-4D97-AF65-F5344CB8AC3E}">
+        <p14:creationId xmlns:p14="http://schemas.microsoft.com/office/powerpoint/2010/main" val="727027711"/>
+      </p:ext>
+    </p:extLst>
   </p:cSld>
   <p:clrMapOvr>
     <a:masterClrMapping/>
@@ -3240,6 +3320,7 @@
           <a:p>
             <a:fld id="{5BCAD085-E8A6-8845-BD4E-CB4CCA059FC4}" type="datetimeFigureOut">
               <a:rPr lang="en-US" smtClean="0"/>
+              <a:t>1/27/13</a:t>
             </a:fld>
             <a:endParaRPr lang="en-US"/>
           </a:p>
@@ -3281,12 +3362,18 @@
           <a:p>
             <a:fld id="{C1FF6DA9-008F-8B48-92A6-B652298478BF}" type="slidenum">
               <a:rPr lang="en-US" smtClean="0"/>
+              <a:t>‹#›</a:t>
             </a:fld>
             <a:endParaRPr lang="en-US"/>
           </a:p>
         </p:txBody>
       </p:sp>
     </p:spTree>
+    <p:extLst>
+      <p:ext uri="{BB962C8B-B14F-4D97-AF65-F5344CB8AC3E}">
+        <p14:creationId xmlns:p14="http://schemas.microsoft.com/office/powerpoint/2010/main" val="1212999818"/>
+      </p:ext>
+    </p:extLst>
   </p:cSld>
   <p:clrMapOvr>
     <a:masterClrMapping/>
@@ -3396,7 +3483,6 @@
               <a:rPr lang="en-US" smtClean="0"/>
               <a:t>Click to edit Master text styles</a:t>
             </a:r>
-            <a:endParaRPr lang="en-US" smtClean="0"/>
           </a:p>
           <a:p>
             <a:pPr lvl="1"/>
@@ -3404,7 +3490,6 @@
               <a:rPr lang="en-US" smtClean="0"/>
               <a:t>Second level</a:t>
             </a:r>
-            <a:endParaRPr lang="en-US" smtClean="0"/>
           </a:p>
           <a:p>
             <a:pPr lvl="2"/>
@@ -3412,7 +3497,6 @@
               <a:rPr lang="en-US" smtClean="0"/>
               <a:t>Third level</a:t>
             </a:r>
-            <a:endParaRPr lang="en-US" smtClean="0"/>
           </a:p>
           <a:p>
             <a:pPr lvl="3"/>
@@ -3420,7 +3504,6 @@
               <a:rPr lang="en-US" smtClean="0"/>
               <a:t>Fourth level</a:t>
             </a:r>
-            <a:endParaRPr lang="en-US" smtClean="0"/>
           </a:p>
           <a:p>
             <a:pPr lvl="4"/>
@@ -3494,7 +3577,6 @@
               <a:rPr lang="en-US" smtClean="0"/>
               <a:t>Click to edit Master text styles</a:t>
             </a:r>
-            <a:endParaRPr lang="en-US" smtClean="0"/>
           </a:p>
         </p:txBody>
       </p:sp>
@@ -3515,6 +3597,7 @@
           <a:p>
             <a:fld id="{5BCAD085-E8A6-8845-BD4E-CB4CCA059FC4}" type="datetimeFigureOut">
               <a:rPr lang="en-US" smtClean="0"/>
+              <a:t>1/27/13</a:t>
             </a:fld>
             <a:endParaRPr lang="en-US"/>
           </a:p>
@@ -3556,12 +3639,18 @@
           <a:p>
             <a:fld id="{C1FF6DA9-008F-8B48-92A6-B652298478BF}" type="slidenum">
               <a:rPr lang="en-US" smtClean="0"/>
+              <a:t>‹#›</a:t>
             </a:fld>
             <a:endParaRPr lang="en-US"/>
           </a:p>
         </p:txBody>
       </p:sp>
     </p:spTree>
+    <p:extLst>
+      <p:ext uri="{BB962C8B-B14F-4D97-AF65-F5344CB8AC3E}">
+        <p14:creationId xmlns:p14="http://schemas.microsoft.com/office/powerpoint/2010/main" val="1840726560"/>
+      </p:ext>
+    </p:extLst>
   </p:cSld>
   <p:clrMapOvr>
     <a:masterClrMapping/>
@@ -3741,7 +3830,6 @@
               <a:rPr lang="en-US" smtClean="0"/>
               <a:t>Click to edit Master text styles</a:t>
             </a:r>
-            <a:endParaRPr lang="en-US" smtClean="0"/>
           </a:p>
         </p:txBody>
       </p:sp>
@@ -3762,6 +3850,7 @@
           <a:p>
             <a:fld id="{5BCAD085-E8A6-8845-BD4E-CB4CCA059FC4}" type="datetimeFigureOut">
               <a:rPr lang="en-US" smtClean="0"/>
+              <a:t>1/27/13</a:t>
             </a:fld>
             <a:endParaRPr lang="en-US"/>
           </a:p>
@@ -3803,12 +3892,18 @@
           <a:p>
             <a:fld id="{C1FF6DA9-008F-8B48-92A6-B652298478BF}" type="slidenum">
               <a:rPr lang="en-US" smtClean="0"/>
+              <a:t>‹#›</a:t>
             </a:fld>
             <a:endParaRPr lang="en-US"/>
           </a:p>
         </p:txBody>
       </p:sp>
     </p:spTree>
+    <p:extLst>
+      <p:ext uri="{BB962C8B-B14F-4D97-AF65-F5344CB8AC3E}">
+        <p14:creationId xmlns:p14="http://schemas.microsoft.com/office/powerpoint/2010/main" val="3889236939"/>
+      </p:ext>
+    </p:extLst>
   </p:cSld>
   <p:clrMapOvr>
     <a:masterClrMapping/>
@@ -3901,7 +3996,6 @@
               <a:rPr lang="en-US" smtClean="0"/>
               <a:t>Click to edit Master text styles</a:t>
             </a:r>
-            <a:endParaRPr lang="en-US" smtClean="0"/>
           </a:p>
           <a:p>
             <a:pPr lvl="1"/>
@@ -3909,7 +4003,6 @@
               <a:rPr lang="en-US" smtClean="0"/>
               <a:t>Second level</a:t>
             </a:r>
-            <a:endParaRPr lang="en-US" smtClean="0"/>
           </a:p>
           <a:p>
             <a:pPr lvl="2"/>
@@ -3917,7 +4010,6 @@
               <a:rPr lang="en-US" smtClean="0"/>
               <a:t>Third level</a:t>
             </a:r>
-            <a:endParaRPr lang="en-US" smtClean="0"/>
           </a:p>
           <a:p>
             <a:pPr lvl="3"/>
@@ -3925,7 +4017,6 @@
               <a:rPr lang="en-US" smtClean="0"/>
               <a:t>Fourth level</a:t>
             </a:r>
-            <a:endParaRPr lang="en-US" smtClean="0"/>
           </a:p>
           <a:p>
             <a:pPr lvl="4"/>
@@ -3972,6 +4063,7 @@
           <a:p>
             <a:fld id="{5BCAD085-E8A6-8845-BD4E-CB4CCA059FC4}" type="datetimeFigureOut">
               <a:rPr lang="en-US" smtClean="0"/>
+              <a:t>1/27/13</a:t>
             </a:fld>
             <a:endParaRPr lang="en-US"/>
           </a:p>
@@ -4049,12 +4141,18 @@
           <a:p>
             <a:fld id="{C1FF6DA9-008F-8B48-92A6-B652298478BF}" type="slidenum">
               <a:rPr lang="en-US" smtClean="0"/>
+              <a:t>‹#›</a:t>
             </a:fld>
             <a:endParaRPr lang="en-US"/>
           </a:p>
         </p:txBody>
       </p:sp>
     </p:spTree>
+    <p:extLst>
+      <p:ext uri="{BB962C8B-B14F-4D97-AF65-F5344CB8AC3E}">
+        <p14:creationId xmlns:p14="http://schemas.microsoft.com/office/powerpoint/2010/main" val="2209977519"/>
+      </p:ext>
+    </p:extLst>
   </p:cSld>
   <p:clrMap bg1="lt1" tx1="dk1" bg2="lt2" tx2="dk2" accent1="accent1" accent2="accent2" accent3="accent3" accent4="accent4" accent5="accent5" accent6="accent6" hlink="hlink" folHlink="folHlink"/>
   <p:sldLayoutIdLst>
@@ -4092,7 +4190,7 @@
         <a:spcBef>
           <a:spcPct val="20000"/>
         </a:spcBef>
-        <a:buFont typeface="Arial" panose="020B0604020202020204"/>
+        <a:buFont typeface="Arial"/>
         <a:buChar char="•"/>
         <a:defRPr sz="3200" kern="1200">
           <a:solidFill>
@@ -4107,7 +4205,7 @@
         <a:spcBef>
           <a:spcPct val="20000"/>
         </a:spcBef>
-        <a:buFont typeface="Arial" panose="020B0604020202020204"/>
+        <a:buFont typeface="Arial"/>
         <a:buChar char="–"/>
         <a:defRPr sz="2800" kern="1200">
           <a:solidFill>
@@ -4122,7 +4220,7 @@
         <a:spcBef>
           <a:spcPct val="20000"/>
         </a:spcBef>
-        <a:buFont typeface="Arial" panose="020B0604020202020204"/>
+        <a:buFont typeface="Arial"/>
         <a:buChar char="•"/>
         <a:defRPr sz="2400" kern="1200">
           <a:solidFill>
@@ -4137,7 +4235,7 @@
         <a:spcBef>
           <a:spcPct val="20000"/>
         </a:spcBef>
-        <a:buFont typeface="Arial" panose="020B0604020202020204"/>
+        <a:buFont typeface="Arial"/>
         <a:buChar char="–"/>
         <a:defRPr sz="2000" kern="1200">
           <a:solidFill>
@@ -4152,7 +4250,7 @@
         <a:spcBef>
           <a:spcPct val="20000"/>
         </a:spcBef>
-        <a:buFont typeface="Arial" panose="020B0604020202020204"/>
+        <a:buFont typeface="Arial"/>
         <a:buChar char="»"/>
         <a:defRPr sz="2000" kern="1200">
           <a:solidFill>
@@ -4167,7 +4265,7 @@
         <a:spcBef>
           <a:spcPct val="20000"/>
         </a:spcBef>
-        <a:buFont typeface="Arial" panose="020B0604020202020204"/>
+        <a:buFont typeface="Arial"/>
         <a:buChar char="•"/>
         <a:defRPr sz="2000" kern="1200">
           <a:solidFill>
@@ -4182,7 +4280,7 @@
         <a:spcBef>
           <a:spcPct val="20000"/>
         </a:spcBef>
-        <a:buFont typeface="Arial" panose="020B0604020202020204"/>
+        <a:buFont typeface="Arial"/>
         <a:buChar char="•"/>
         <a:defRPr sz="2000" kern="1200">
           <a:solidFill>
@@ -4197,7 +4295,7 @@
         <a:spcBef>
           <a:spcPct val="20000"/>
         </a:spcBef>
-        <a:buFont typeface="Arial" panose="020B0604020202020204"/>
+        <a:buFont typeface="Arial"/>
         <a:buChar char="•"/>
         <a:defRPr sz="2000" kern="1200">
           <a:solidFill>
@@ -4212,7 +4310,7 @@
         <a:spcBef>
           <a:spcPct val="20000"/>
         </a:spcBef>
-        <a:buFont typeface="Arial" panose="020B0604020202020204"/>
+        <a:buFont typeface="Arial"/>
         <a:buChar char="•"/>
         <a:defRPr sz="2000" kern="1200">
           <a:solidFill>
@@ -4324,7 +4422,7 @@
 </file>
 
 <file path=ppt/slides/slide1.xml><?xml version="1.0" encoding="utf-8"?>
-<p:sld xmlns:a="http://schemas.openxmlformats.org/drawingml/2006/main" xmlns:r="http://schemas.openxmlformats.org/officeDocument/2006/relationships" xmlns:p="http://schemas.openxmlformats.org/presentationml/2006/main">
+<p:sld xmlns:a="http://schemas.openxmlformats.org/drawingml/2006/main" xmlns:p="http://schemas.openxmlformats.org/presentationml/2006/main" xmlns:r="http://schemas.openxmlformats.org/officeDocument/2006/relationships">
   <p:cSld>
     <p:spTree>
       <p:nvGrpSpPr>
@@ -4342,7 +4440,7 @@
           <p:nvPr/>
         </p:nvPicPr>
         <p:blipFill>
-          <a:blip r:embed="rId1"/>
+          <a:blip r:embed="rId2"/>
           <a:stretch>
             <a:fillRect/>
           </a:stretch>
@@ -4385,16 +4483,10 @@
                 <a:solidFill>
                   <a:srgbClr val="94A3B8"/>
                 </a:solidFill>
-                <a:latin typeface="微软雅黑" panose="020B0503020204020204" charset="-122"/>
+                <a:latin typeface="Microsoft YaHei"/>
               </a:rPr>
-              <a:t>1/13</a:t>
-            </a:r>
-            <a:endParaRPr sz="1000">
-              <a:solidFill>
-                <a:srgbClr val="94A3B8"/>
-              </a:solidFill>
-              <a:latin typeface="微软雅黑" panose="020B0503020204020204" charset="-122"/>
-            </a:endParaRPr>
+              <a:t>1/14</a:t>
+            </a:r>
           </a:p>
         </p:txBody>
       </p:sp>
@@ -4407,7 +4499,7 @@
 </file>
 
 <file path=ppt/slides/slide10.xml><?xml version="1.0" encoding="utf-8"?>
-<p:sld xmlns:a="http://schemas.openxmlformats.org/drawingml/2006/main" xmlns:r="http://schemas.openxmlformats.org/officeDocument/2006/relationships" xmlns:p="http://schemas.openxmlformats.org/presentationml/2006/main">
+<p:sld xmlns:a="http://schemas.openxmlformats.org/drawingml/2006/main" xmlns:p="http://schemas.openxmlformats.org/presentationml/2006/main" xmlns:r="http://schemas.openxmlformats.org/officeDocument/2006/relationships">
   <p:cSld>
     <p:spTree>
       <p:nvGrpSpPr>
@@ -4418,14 +4510,14 @@
       <p:grpSpPr/>
       <p:pic>
         <p:nvPicPr>
-          <p:cNvPr id="2" name="Picture 1" descr="10_business_value.png"/>
+          <p:cNvPr id="2" name="Picture 1" descr="10_five_dimensions.png"/>
           <p:cNvPicPr>
             <a:picLocks noChangeAspect="1"/>
           </p:cNvPicPr>
           <p:nvPr/>
         </p:nvPicPr>
         <p:blipFill>
-          <a:blip r:embed="rId1"/>
+          <a:blip r:embed="rId2"/>
           <a:stretch>
             <a:fillRect/>
           </a:stretch>
@@ -4468,16 +4560,10 @@
                 <a:solidFill>
                   <a:srgbClr val="94A3B8"/>
                 </a:solidFill>
-                <a:latin typeface="微软雅黑" panose="020B0503020204020204" charset="-122"/>
+                <a:latin typeface="Microsoft YaHei"/>
               </a:rPr>
-              <a:t>10/13</a:t>
-            </a:r>
-            <a:endParaRPr sz="1000">
-              <a:solidFill>
-                <a:srgbClr val="94A3B8"/>
-              </a:solidFill>
-              <a:latin typeface="微软雅黑" panose="020B0503020204020204" charset="-122"/>
-            </a:endParaRPr>
+              <a:t>10/14</a:t>
+            </a:r>
           </a:p>
         </p:txBody>
       </p:sp>
@@ -4490,7 +4576,7 @@
 </file>
 
 <file path=ppt/slides/slide11.xml><?xml version="1.0" encoding="utf-8"?>
-<p:sld xmlns:a="http://schemas.openxmlformats.org/drawingml/2006/main" xmlns:r="http://schemas.openxmlformats.org/officeDocument/2006/relationships" xmlns:p="http://schemas.openxmlformats.org/presentationml/2006/main">
+<p:sld xmlns:a="http://schemas.openxmlformats.org/drawingml/2006/main" xmlns:p="http://schemas.openxmlformats.org/presentationml/2006/main" xmlns:r="http://schemas.openxmlformats.org/officeDocument/2006/relationships">
   <p:cSld>
     <p:spTree>
       <p:nvGrpSpPr>
@@ -4501,14 +4587,14 @@
       <p:grpSpPr/>
       <p:pic>
         <p:nvPicPr>
-          <p:cNvPr id="2" name="Picture 1" descr="11_demo_proof.png"/>
+          <p:cNvPr id="2" name="Picture 1" descr="11_business_value.png"/>
           <p:cNvPicPr>
             <a:picLocks noChangeAspect="1"/>
           </p:cNvPicPr>
           <p:nvPr/>
         </p:nvPicPr>
         <p:blipFill>
-          <a:blip r:embed="rId1"/>
+          <a:blip r:embed="rId2"/>
           <a:stretch>
             <a:fillRect/>
           </a:stretch>
@@ -4551,16 +4637,10 @@
                 <a:solidFill>
                   <a:srgbClr val="94A3B8"/>
                 </a:solidFill>
-                <a:latin typeface="微软雅黑" panose="020B0503020204020204" charset="-122"/>
+                <a:latin typeface="Microsoft YaHei"/>
               </a:rPr>
-              <a:t>11/13</a:t>
-            </a:r>
-            <a:endParaRPr sz="1000">
-              <a:solidFill>
-                <a:srgbClr val="94A3B8"/>
-              </a:solidFill>
-              <a:latin typeface="微软雅黑" panose="020B0503020204020204" charset="-122"/>
-            </a:endParaRPr>
+              <a:t>11/14</a:t>
+            </a:r>
           </a:p>
         </p:txBody>
       </p:sp>
@@ -4573,7 +4653,7 @@
 </file>
 
 <file path=ppt/slides/slide12.xml><?xml version="1.0" encoding="utf-8"?>
-<p:sld xmlns:a="http://schemas.openxmlformats.org/drawingml/2006/main" xmlns:r="http://schemas.openxmlformats.org/officeDocument/2006/relationships" xmlns:p="http://schemas.openxmlformats.org/presentationml/2006/main">
+<p:sld xmlns:a="http://schemas.openxmlformats.org/drawingml/2006/main" xmlns:p="http://schemas.openxmlformats.org/presentationml/2006/main" xmlns:r="http://schemas.openxmlformats.org/officeDocument/2006/relationships">
   <p:cSld>
     <p:spTree>
       <p:nvGrpSpPr>
@@ -4584,14 +4664,14 @@
       <p:grpSpPr/>
       <p:pic>
         <p:nvPicPr>
-          <p:cNvPr id="2" name="Picture 1" descr="12_roadmap.png"/>
+          <p:cNvPr id="2" name="Picture 1" descr="12_demo_proof.png"/>
           <p:cNvPicPr>
             <a:picLocks noChangeAspect="1"/>
           </p:cNvPicPr>
           <p:nvPr/>
         </p:nvPicPr>
         <p:blipFill>
-          <a:blip r:embed="rId1"/>
+          <a:blip r:embed="rId2"/>
           <a:stretch>
             <a:fillRect/>
           </a:stretch>
@@ -4634,16 +4714,10 @@
                 <a:solidFill>
                   <a:srgbClr val="94A3B8"/>
                 </a:solidFill>
-                <a:latin typeface="微软雅黑" panose="020B0503020204020204" charset="-122"/>
+                <a:latin typeface="Microsoft YaHei"/>
               </a:rPr>
-              <a:t>12/13</a:t>
-            </a:r>
-            <a:endParaRPr sz="1000">
-              <a:solidFill>
-                <a:srgbClr val="94A3B8"/>
-              </a:solidFill>
-              <a:latin typeface="微软雅黑" panose="020B0503020204020204" charset="-122"/>
-            </a:endParaRPr>
+              <a:t>12/14</a:t>
+            </a:r>
           </a:p>
         </p:txBody>
       </p:sp>
@@ -4656,7 +4730,7 @@
 </file>
 
 <file path=ppt/slides/slide13.xml><?xml version="1.0" encoding="utf-8"?>
-<p:sld xmlns:a="http://schemas.openxmlformats.org/drawingml/2006/main" xmlns:r="http://schemas.openxmlformats.org/officeDocument/2006/relationships" xmlns:p="http://schemas.openxmlformats.org/presentationml/2006/main">
+<p:sld xmlns:a="http://schemas.openxmlformats.org/drawingml/2006/main" xmlns:p="http://schemas.openxmlformats.org/presentationml/2006/main" xmlns:r="http://schemas.openxmlformats.org/officeDocument/2006/relationships">
   <p:cSld>
     <p:spTree>
       <p:nvGrpSpPr>
@@ -4667,14 +4741,14 @@
       <p:grpSpPr/>
       <p:pic>
         <p:nvPicPr>
-          <p:cNvPr id="2" name="Picture 1" descr="13_thanks.png"/>
+          <p:cNvPr id="2" name="Picture 1" descr="13_roadmap.png"/>
           <p:cNvPicPr>
             <a:picLocks noChangeAspect="1"/>
           </p:cNvPicPr>
           <p:nvPr/>
         </p:nvPicPr>
         <p:blipFill>
-          <a:blip r:embed="rId1"/>
+          <a:blip r:embed="rId2"/>
           <a:stretch>
             <a:fillRect/>
           </a:stretch>
@@ -4717,16 +4791,87 @@
                 <a:solidFill>
                   <a:srgbClr val="94A3B8"/>
                 </a:solidFill>
-                <a:latin typeface="微软雅黑" panose="020B0503020204020204" charset="-122"/>
+                <a:latin typeface="Microsoft YaHei"/>
               </a:rPr>
-              <a:t>13/13</a:t>
-            </a:r>
-            <a:endParaRPr sz="1000">
-              <a:solidFill>
-                <a:srgbClr val="94A3B8"/>
-              </a:solidFill>
-              <a:latin typeface="微软雅黑" panose="020B0503020204020204" charset="-122"/>
-            </a:endParaRPr>
+              <a:t>13/14</a:t>
+            </a:r>
+          </a:p>
+        </p:txBody>
+      </p:sp>
+    </p:spTree>
+  </p:cSld>
+  <p:clrMapOvr>
+    <a:masterClrMapping/>
+  </p:clrMapOvr>
+</p:sld>
+</file>
+
+<file path=ppt/slides/slide14.xml><?xml version="1.0" encoding="utf-8"?>
+<p:sld xmlns:a="http://schemas.openxmlformats.org/drawingml/2006/main" xmlns:p="http://schemas.openxmlformats.org/presentationml/2006/main" xmlns:r="http://schemas.openxmlformats.org/officeDocument/2006/relationships">
+  <p:cSld>
+    <p:spTree>
+      <p:nvGrpSpPr>
+        <p:cNvPr id="1" name=""/>
+        <p:cNvGrpSpPr/>
+        <p:nvPr/>
+      </p:nvGrpSpPr>
+      <p:grpSpPr/>
+      <p:pic>
+        <p:nvPicPr>
+          <p:cNvPr id="2" name="Picture 1" descr="14_thanks.png"/>
+          <p:cNvPicPr>
+            <a:picLocks noChangeAspect="1"/>
+          </p:cNvPicPr>
+          <p:nvPr/>
+        </p:nvPicPr>
+        <p:blipFill>
+          <a:blip r:embed="rId2"/>
+          <a:stretch>
+            <a:fillRect/>
+          </a:stretch>
+        </p:blipFill>
+        <p:spPr>
+          <a:xfrm>
+            <a:off x="0" y="0"/>
+            <a:ext cx="12191695" cy="6858000"/>
+          </a:xfrm>
+          <a:prstGeom prst="rect">
+            <a:avLst/>
+          </a:prstGeom>
+        </p:spPr>
+      </p:pic>
+      <p:sp>
+        <p:nvSpPr>
+          <p:cNvPr id="3" name="TextBox 2"/>
+          <p:cNvSpPr txBox="1"/>
+          <p:nvPr/>
+        </p:nvSpPr>
+        <p:spPr>
+          <a:xfrm>
+            <a:off x="10972800" y="6537960"/>
+            <a:ext cx="1005840" cy="256032"/>
+          </a:xfrm>
+          <a:prstGeom prst="rect">
+            <a:avLst/>
+          </a:prstGeom>
+          <a:noFill/>
+        </p:spPr>
+        <p:txBody>
+          <a:bodyPr wrap="none">
+            <a:spAutoFit/>
+          </a:bodyPr>
+          <a:lstStyle/>
+          <a:p>
+            <a:pPr algn="r"/>
+            <a:r>
+              <a:rPr sz="1000">
+                <a:solidFill>
+                  <a:srgbClr val="94A3B8"/>
+                </a:solidFill>
+                <a:latin typeface="Microsoft YaHei"/>
+              </a:rPr>
+              <a:t>14/14</a:t>
+            </a:r>
           </a:p>
         </p:txBody>
       </p:sp>
@@ -4739,7 +4884,7 @@
 </file>
 
 <file path=ppt/slides/slide2.xml><?xml version="1.0" encoding="utf-8"?>
-<p:sld xmlns:a="http://schemas.openxmlformats.org/drawingml/2006/main" xmlns:r="http://schemas.openxmlformats.org/officeDocument/2006/relationships" xmlns:p="http://schemas.openxmlformats.org/presentationml/2006/main">
+<p:sld xmlns:a="http://schemas.openxmlformats.org/drawingml/2006/main" xmlns:p="http://schemas.openxmlformats.org/presentationml/2006/main" xmlns:r="http://schemas.openxmlformats.org/officeDocument/2006/relationships">
   <p:cSld>
     <p:spTree>
       <p:nvGrpSpPr>
@@ -4757,7 +4902,7 @@
           <p:nvPr/>
         </p:nvPicPr>
         <p:blipFill>
-          <a:blip r:embed="rId1"/>
+          <a:blip r:embed="rId2"/>
           <a:stretch>
             <a:fillRect/>
           </a:stretch>
@@ -4800,16 +4945,10 @@
                 <a:solidFill>
                   <a:srgbClr val="94A3B8"/>
                 </a:solidFill>
-                <a:latin typeface="微软雅黑" panose="020B0503020204020204" charset="-122"/>
+                <a:latin typeface="Microsoft YaHei"/>
               </a:rPr>
-              <a:t>2/13</a:t>
-            </a:r>
-            <a:endParaRPr sz="1000">
-              <a:solidFill>
-                <a:srgbClr val="94A3B8"/>
-              </a:solidFill>
-              <a:latin typeface="微软雅黑" panose="020B0503020204020204" charset="-122"/>
-            </a:endParaRPr>
+              <a:t>2/14</a:t>
+            </a:r>
           </a:p>
         </p:txBody>
       </p:sp>
@@ -4822,7 +4961,7 @@
 </file>
 
 <file path=ppt/slides/slide3.xml><?xml version="1.0" encoding="utf-8"?>
-<p:sld xmlns:a="http://schemas.openxmlformats.org/drawingml/2006/main" xmlns:r="http://schemas.openxmlformats.org/officeDocument/2006/relationships" xmlns:p="http://schemas.openxmlformats.org/presentationml/2006/main">
+<p:sld xmlns:a="http://schemas.openxmlformats.org/drawingml/2006/main" xmlns:p="http://schemas.openxmlformats.org/presentationml/2006/main" xmlns:r="http://schemas.openxmlformats.org/officeDocument/2006/relationships">
   <p:cSld>
     <p:spTree>
       <p:nvGrpSpPr>
@@ -4840,7 +4979,7 @@
           <p:nvPr/>
         </p:nvPicPr>
         <p:blipFill>
-          <a:blip r:embed="rId1"/>
+          <a:blip r:embed="rId2"/>
           <a:stretch>
             <a:fillRect/>
           </a:stretch>
@@ -4883,16 +5022,10 @@
                 <a:solidFill>
                   <a:srgbClr val="94A3B8"/>
                 </a:solidFill>
-                <a:latin typeface="微软雅黑" panose="020B0503020204020204" charset="-122"/>
+                <a:latin typeface="Microsoft YaHei"/>
               </a:rPr>
-              <a:t>3/13</a:t>
-            </a:r>
-            <a:endParaRPr sz="1000">
-              <a:solidFill>
-                <a:srgbClr val="94A3B8"/>
-              </a:solidFill>
-              <a:latin typeface="微软雅黑" panose="020B0503020204020204" charset="-122"/>
-            </a:endParaRPr>
+              <a:t>3/14</a:t>
+            </a:r>
           </a:p>
         </p:txBody>
       </p:sp>
@@ -4905,7 +5038,7 @@
 </file>
 
 <file path=ppt/slides/slide4.xml><?xml version="1.0" encoding="utf-8"?>
-<p:sld xmlns:a="http://schemas.openxmlformats.org/drawingml/2006/main" xmlns:r="http://schemas.openxmlformats.org/officeDocument/2006/relationships" xmlns:p="http://schemas.openxmlformats.org/presentationml/2006/main">
+<p:sld xmlns:a="http://schemas.openxmlformats.org/drawingml/2006/main" xmlns:p="http://schemas.openxmlformats.org/presentationml/2006/main" xmlns:r="http://schemas.openxmlformats.org/officeDocument/2006/relationships">
   <p:cSld>
     <p:spTree>
       <p:nvGrpSpPr>
@@ -4923,7 +5056,7 @@
           <p:nvPr/>
         </p:nvPicPr>
         <p:blipFill>
-          <a:blip r:embed="rId1"/>
+          <a:blip r:embed="rId2"/>
           <a:stretch>
             <a:fillRect/>
           </a:stretch>
@@ -4966,16 +5099,10 @@
                 <a:solidFill>
                   <a:srgbClr val="94A3B8"/>
                 </a:solidFill>
-                <a:latin typeface="微软雅黑" panose="020B0503020204020204" charset="-122"/>
+                <a:latin typeface="Microsoft YaHei"/>
               </a:rPr>
-              <a:t>4/13</a:t>
-            </a:r>
-            <a:endParaRPr sz="1000">
-              <a:solidFill>
-                <a:srgbClr val="94A3B8"/>
-              </a:solidFill>
-              <a:latin typeface="微软雅黑" panose="020B0503020204020204" charset="-122"/>
-            </a:endParaRPr>
+              <a:t>4/14</a:t>
+            </a:r>
           </a:p>
         </p:txBody>
       </p:sp>
@@ -4988,7 +5115,7 @@
 </file>
 
 <file path=ppt/slides/slide5.xml><?xml version="1.0" encoding="utf-8"?>
-<p:sld xmlns:a="http://schemas.openxmlformats.org/drawingml/2006/main" xmlns:r="http://schemas.openxmlformats.org/officeDocument/2006/relationships" xmlns:p="http://schemas.openxmlformats.org/presentationml/2006/main">
+<p:sld xmlns:a="http://schemas.openxmlformats.org/drawingml/2006/main" xmlns:p="http://schemas.openxmlformats.org/presentationml/2006/main" xmlns:r="http://schemas.openxmlformats.org/officeDocument/2006/relationships">
   <p:cSld>
     <p:spTree>
       <p:nvGrpSpPr>
@@ -5006,7 +5133,7 @@
           <p:nvPr/>
         </p:nvPicPr>
         <p:blipFill>
-          <a:blip r:embed="rId1"/>
+          <a:blip r:embed="rId2"/>
           <a:stretch>
             <a:fillRect/>
           </a:stretch>
@@ -5049,16 +5176,10 @@
                 <a:solidFill>
                   <a:srgbClr val="94A3B8"/>
                 </a:solidFill>
-                <a:latin typeface="微软雅黑" panose="020B0503020204020204" charset="-122"/>
+                <a:latin typeface="Microsoft YaHei"/>
               </a:rPr>
-              <a:t>5/13</a:t>
-            </a:r>
-            <a:endParaRPr sz="1000">
-              <a:solidFill>
-                <a:srgbClr val="94A3B8"/>
-              </a:solidFill>
-              <a:latin typeface="微软雅黑" panose="020B0503020204020204" charset="-122"/>
-            </a:endParaRPr>
+              <a:t>5/14</a:t>
+            </a:r>
           </a:p>
         </p:txBody>
       </p:sp>
@@ -5071,7 +5192,7 @@
 </file>
 
 <file path=ppt/slides/slide6.xml><?xml version="1.0" encoding="utf-8"?>
-<p:sld xmlns:a="http://schemas.openxmlformats.org/drawingml/2006/main" xmlns:r="http://schemas.openxmlformats.org/officeDocument/2006/relationships" xmlns:p="http://schemas.openxmlformats.org/presentationml/2006/main">
+<p:sld xmlns:a="http://schemas.openxmlformats.org/drawingml/2006/main" xmlns:p="http://schemas.openxmlformats.org/presentationml/2006/main" xmlns:r="http://schemas.openxmlformats.org/officeDocument/2006/relationships">
   <p:cSld>
     <p:spTree>
       <p:nvGrpSpPr>
@@ -5089,7 +5210,7 @@
           <p:nvPr/>
         </p:nvPicPr>
         <p:blipFill>
-          <a:blip r:embed="rId1"/>
+          <a:blip r:embed="rId2"/>
           <a:stretch>
             <a:fillRect/>
           </a:stretch>
@@ -5132,16 +5253,10 @@
                 <a:solidFill>
                   <a:srgbClr val="94A3B8"/>
                 </a:solidFill>
-                <a:latin typeface="微软雅黑" panose="020B0503020204020204" charset="-122"/>
+                <a:latin typeface="Microsoft YaHei"/>
               </a:rPr>
-              <a:t>6/13</a:t>
-            </a:r>
-            <a:endParaRPr sz="1000">
-              <a:solidFill>
-                <a:srgbClr val="94A3B8"/>
-              </a:solidFill>
-              <a:latin typeface="微软雅黑" panose="020B0503020204020204" charset="-122"/>
-            </a:endParaRPr>
+              <a:t>6/14</a:t>
+            </a:r>
           </a:p>
         </p:txBody>
       </p:sp>
@@ -5154,7 +5269,7 @@
 </file>
 
 <file path=ppt/slides/slide7.xml><?xml version="1.0" encoding="utf-8"?>
-<p:sld xmlns:a="http://schemas.openxmlformats.org/drawingml/2006/main" xmlns:r="http://schemas.openxmlformats.org/officeDocument/2006/relationships" xmlns:p="http://schemas.openxmlformats.org/presentationml/2006/main">
+<p:sld xmlns:a="http://schemas.openxmlformats.org/drawingml/2006/main" xmlns:p="http://schemas.openxmlformats.org/presentationml/2006/main" xmlns:r="http://schemas.openxmlformats.org/officeDocument/2006/relationships">
   <p:cSld>
     <p:spTree>
       <p:nvGrpSpPr>
@@ -5165,14 +5280,14 @@
       <p:grpSpPr/>
       <p:pic>
         <p:nvPicPr>
-          <p:cNvPr id="2" name="Picture 1" descr="07_metrics.png"/>
+          <p:cNvPr id="2" name="Picture 1" descr="07_llm_provider.png"/>
           <p:cNvPicPr>
             <a:picLocks noChangeAspect="1"/>
           </p:cNvPicPr>
           <p:nvPr/>
         </p:nvPicPr>
         <p:blipFill>
-          <a:blip r:embed="rId1"/>
+          <a:blip r:embed="rId2"/>
           <a:stretch>
             <a:fillRect/>
           </a:stretch>
@@ -5215,16 +5330,10 @@
                 <a:solidFill>
                   <a:srgbClr val="94A3B8"/>
                 </a:solidFill>
-                <a:latin typeface="微软雅黑" panose="020B0503020204020204" charset="-122"/>
+                <a:latin typeface="Microsoft YaHei"/>
               </a:rPr>
-              <a:t>7/13</a:t>
-            </a:r>
-            <a:endParaRPr sz="1000">
-              <a:solidFill>
-                <a:srgbClr val="94A3B8"/>
-              </a:solidFill>
-              <a:latin typeface="微软雅黑" panose="020B0503020204020204" charset="-122"/>
-            </a:endParaRPr>
+              <a:t>7/14</a:t>
+            </a:r>
           </a:p>
         </p:txBody>
       </p:sp>
@@ -5237,7 +5346,7 @@
 </file>
 
 <file path=ppt/slides/slide8.xml><?xml version="1.0" encoding="utf-8"?>
-<p:sld xmlns:a="http://schemas.openxmlformats.org/drawingml/2006/main" xmlns:r="http://schemas.openxmlformats.org/officeDocument/2006/relationships" xmlns:p="http://schemas.openxmlformats.org/presentationml/2006/main">
+<p:sld xmlns:a="http://schemas.openxmlformats.org/drawingml/2006/main" xmlns:p="http://schemas.openxmlformats.org/presentationml/2006/main" xmlns:r="http://schemas.openxmlformats.org/officeDocument/2006/relationships">
   <p:cSld>
     <p:spTree>
       <p:nvGrpSpPr>
@@ -5248,14 +5357,14 @@
       <p:grpSpPr/>
       <p:pic>
         <p:nvPicPr>
-          <p:cNvPr id="2" name="Picture 1" descr="08_evidence_matrix.png"/>
+          <p:cNvPr id="2" name="Picture 1" descr="08_metrics.png"/>
           <p:cNvPicPr>
             <a:picLocks noChangeAspect="1"/>
           </p:cNvPicPr>
           <p:nvPr/>
         </p:nvPicPr>
         <p:blipFill>
-          <a:blip r:embed="rId1"/>
+          <a:blip r:embed="rId2"/>
           <a:stretch>
             <a:fillRect/>
           </a:stretch>
@@ -5298,16 +5407,10 @@
                 <a:solidFill>
                   <a:srgbClr val="94A3B8"/>
                 </a:solidFill>
-                <a:latin typeface="微软雅黑" panose="020B0503020204020204" charset="-122"/>
+                <a:latin typeface="Microsoft YaHei"/>
               </a:rPr>
-              <a:t>8/13</a:t>
-            </a:r>
-            <a:endParaRPr sz="1000">
-              <a:solidFill>
-                <a:srgbClr val="94A3B8"/>
-              </a:solidFill>
-              <a:latin typeface="微软雅黑" panose="020B0503020204020204" charset="-122"/>
-            </a:endParaRPr>
+              <a:t>8/14</a:t>
+            </a:r>
           </a:p>
         </p:txBody>
       </p:sp>
@@ -5320,7 +5423,7 @@
 </file>
 
 <file path=ppt/slides/slide9.xml><?xml version="1.0" encoding="utf-8"?>
-<p:sld xmlns:a="http://schemas.openxmlformats.org/drawingml/2006/main" xmlns:r="http://schemas.openxmlformats.org/officeDocument/2006/relationships" xmlns:p="http://schemas.openxmlformats.org/presentationml/2006/main">
+<p:sld xmlns:a="http://schemas.openxmlformats.org/drawingml/2006/main" xmlns:p="http://schemas.openxmlformats.org/presentationml/2006/main" xmlns:r="http://schemas.openxmlformats.org/officeDocument/2006/relationships">
   <p:cSld>
     <p:spTree>
       <p:nvGrpSpPr>
@@ -5331,14 +5434,14 @@
       <p:grpSpPr/>
       <p:pic>
         <p:nvPicPr>
-          <p:cNvPr id="2" name="Picture 1" descr="09_five_dimensions.png"/>
+          <p:cNvPr id="2" name="Picture 1" descr="09_evidence_matrix.png"/>
           <p:cNvPicPr>
             <a:picLocks noChangeAspect="1"/>
           </p:cNvPicPr>
           <p:nvPr/>
         </p:nvPicPr>
         <p:blipFill>
-          <a:blip r:embed="rId1"/>
+          <a:blip r:embed="rId2"/>
           <a:stretch>
             <a:fillRect/>
           </a:stretch>
@@ -5381,16 +5484,10 @@
                 <a:solidFill>
                   <a:srgbClr val="94A3B8"/>
                 </a:solidFill>
-                <a:latin typeface="微软雅黑" panose="020B0503020204020204" charset="-122"/>
+                <a:latin typeface="Microsoft YaHei"/>
               </a:rPr>
-              <a:t>9/13</a:t>
-            </a:r>
-            <a:endParaRPr sz="1000">
-              <a:solidFill>
-                <a:srgbClr val="94A3B8"/>
-              </a:solidFill>
-              <a:latin typeface="微软雅黑" panose="020B0503020204020204" charset="-122"/>
-            </a:endParaRPr>
+              <a:t>9/14</a:t>
+            </a:r>
           </a:p>
         </p:txBody>
       </p:sp>
@@ -5718,11 +5815,7 @@
       </a:style>
     </a:lnDef>
   </a:objectDefaults>
-  <a:extLst>
-    <a:ext uri="{05A4C25C-085E-4340-85A3-A5531E510DB2}">
-      <thm15:themeFamily xmlns:thm15="http://schemas.microsoft.com/office/thememl/2012/main" name="Office Theme" id="{62F939B6-93AF-4DB8-9C6B-D6C7DFDC589F}" vid="{4A3C46E8-61CC-4603-A589-7422A47A8E4A}"/>
-    </a:ext>
-  </a:extLst>
+  <a:extraClrSchemeLst/>
 </a:theme>
 </file>
 
@@ -6042,10 +6135,6 @@
       </a:style>
     </a:lnDef>
   </a:objectDefaults>
-  <a:extLst>
-    <a:ext uri="{05A4C25C-085E-4340-85A3-A5531E510DB2}">
-      <thm15:themeFamily xmlns:thm15="http://schemas.microsoft.com/office/thememl/2012/main" name="Office Theme" id="{62F939B6-93AF-4DB8-9C6B-D6C7DFDC589F}" vid="{4A3C46E8-61CC-4603-A589-7422A47A8E4A}"/>
-    </a:ext>
-  </a:extLst>
+  <a:extraClrSchemeLst/>
 </a:theme>
 </file>
</xml_diff>